<commit_message>
Redesign mentor deck: 3 designed slides (cover / backstory / briefs)
Cover: navy full-bleed, two-tone LEARN|LOOP wordmark, orange spine.
Backstory: 2x2 cards — what it is, new markets, strategy works, system needed —
each with an orange stat line. Briefs: three navy cards (01 SENSE / 02 SPEAK /
03 REACH) with pain + "you build", footer carries the full-system hint only.
Paths/hints/finale content stays in paths-and-hints.md and the runbook.

Co-Authored-By: Claude Fable 5 <noreply@anthropic.com>
</commit_message>
<xml_diff>
--- a/learnloop/mentor-kit/mentor-briefing.pptx
+++ b/learnloop/mentor-kit/mentor-briefing.pptx
@@ -8,15 +8,6 @@
     <p:sldId id="256" r:id="rId7"/>
     <p:sldId id="257" r:id="rId8"/>
     <p:sldId id="258" r:id="rId9"/>
-    <p:sldId id="259" r:id="rId10"/>
-    <p:sldId id="260" r:id="rId11"/>
-    <p:sldId id="261" r:id="rId12"/>
-    <p:sldId id="262" r:id="rId13"/>
-    <p:sldId id="263" r:id="rId14"/>
-    <p:sldId id="264" r:id="rId15"/>
-    <p:sldId id="265" r:id="rId16"/>
-    <p:sldId id="266" r:id="rId17"/>
-    <p:sldId id="267" r:id="rId18"/>
   </p:sldIdLst>
   <p:sldSz cx="12191695" cy="6858000" type="screen4x3"/>
   <p:notesSz cx="6858000" cy="9144000"/>
@@ -3101,14 +3092,146 @@
       <p:grpSpPr/>
       <p:sp>
         <p:nvSpPr>
-          <p:cNvPr id="2" name="TextBox 1"/>
+          <p:cNvPr id="2" name="Rectangle 1"/>
+          <p:cNvSpPr/>
+          <p:nvPr/>
+        </p:nvSpPr>
+        <p:spPr>
+          <a:xfrm>
+            <a:off x="0" y="0"/>
+            <a:ext cx="12191695" cy="6858000"/>
+          </a:xfrm>
+          <a:prstGeom prst="rect">
+            <a:avLst/>
+          </a:prstGeom>
+          <a:solidFill>
+            <a:srgbClr val="14213D"/>
+          </a:solidFill>
+          <a:ln>
+            <a:noFill/>
+          </a:ln>
+          <a:effectLst/>
+        </p:spPr>
+        <p:style>
+          <a:lnRef idx="1">
+            <a:schemeClr val="accent1"/>
+          </a:lnRef>
+          <a:fillRef idx="3">
+            <a:schemeClr val="accent1"/>
+          </a:fillRef>
+          <a:effectRef idx="2">
+            <a:schemeClr val="accent1"/>
+          </a:effectRef>
+          <a:fontRef idx="minor">
+            <a:schemeClr val="lt1"/>
+          </a:fontRef>
+        </p:style>
+        <p:txBody>
+          <a:bodyPr rtlCol="0" anchor="ctr"/>
+          <a:lstStyle/>
+          <a:p>
+            <a:pPr algn="ctr"/>
+          </a:p>
+        </p:txBody>
+      </p:sp>
+      <p:sp>
+        <p:nvSpPr>
+          <p:cNvPr id="3" name="Rectangle 2"/>
+          <p:cNvSpPr/>
+          <p:nvPr/>
+        </p:nvSpPr>
+        <p:spPr>
+          <a:xfrm>
+            <a:off x="0" y="0"/>
+            <a:ext cx="164592" cy="6858000"/>
+          </a:xfrm>
+          <a:prstGeom prst="rect">
+            <a:avLst/>
+          </a:prstGeom>
+          <a:solidFill>
+            <a:srgbClr val="F05A28"/>
+          </a:solidFill>
+          <a:ln>
+            <a:noFill/>
+          </a:ln>
+          <a:effectLst/>
+        </p:spPr>
+        <p:style>
+          <a:lnRef idx="1">
+            <a:schemeClr val="accent1"/>
+          </a:lnRef>
+          <a:fillRef idx="3">
+            <a:schemeClr val="accent1"/>
+          </a:fillRef>
+          <a:effectRef idx="2">
+            <a:schemeClr val="accent1"/>
+          </a:effectRef>
+          <a:fontRef idx="minor">
+            <a:schemeClr val="lt1"/>
+          </a:fontRef>
+        </p:style>
+        <p:txBody>
+          <a:bodyPr rtlCol="0" anchor="ctr"/>
+          <a:lstStyle/>
+          <a:p>
+            <a:pPr algn="ctr"/>
+          </a:p>
+        </p:txBody>
+      </p:sp>
+      <p:sp>
+        <p:nvSpPr>
+          <p:cNvPr id="4" name="Rectangle 3"/>
+          <p:cNvSpPr/>
+          <p:nvPr/>
+        </p:nvSpPr>
+        <p:spPr>
+          <a:xfrm>
+            <a:off x="868680" y="3913632"/>
+            <a:ext cx="2834640" cy="63500"/>
+          </a:xfrm>
+          <a:prstGeom prst="rect">
+            <a:avLst/>
+          </a:prstGeom>
+          <a:solidFill>
+            <a:srgbClr val="F05A28"/>
+          </a:solidFill>
+          <a:ln>
+            <a:noFill/>
+          </a:ln>
+          <a:effectLst/>
+        </p:spPr>
+        <p:style>
+          <a:lnRef idx="1">
+            <a:schemeClr val="accent1"/>
+          </a:lnRef>
+          <a:fillRef idx="3">
+            <a:schemeClr val="accent1"/>
+          </a:fillRef>
+          <a:effectRef idx="2">
+            <a:schemeClr val="accent1"/>
+          </a:effectRef>
+          <a:fontRef idx="minor">
+            <a:schemeClr val="lt1"/>
+          </a:fontRef>
+        </p:style>
+        <p:txBody>
+          <a:bodyPr rtlCol="0" anchor="ctr"/>
+          <a:lstStyle/>
+          <a:p>
+            <a:pPr algn="ctr"/>
+          </a:p>
+        </p:txBody>
+      </p:sp>
+      <p:sp>
+        <p:nvSpPr>
+          <p:cNvPr id="5" name="TextBox 4"/>
           <p:cNvSpPr txBox="1"/>
           <p:nvPr/>
         </p:nvSpPr>
         <p:spPr>
           <a:xfrm>
-            <a:off x="731520" y="2194560"/>
-            <a:ext cx="10698480" cy="1463040"/>
+            <a:off x="822960" y="1234440"/>
+            <a:ext cx="10515600" cy="457200"/>
           </a:xfrm>
           <a:prstGeom prst="rect">
             <a:avLst/>
@@ -3116,34 +3239,37 @@
           <a:noFill/>
         </p:spPr>
         <p:txBody>
-          <a:bodyPr wrap="none">
+          <a:bodyPr wrap="square">
             <a:spAutoFit/>
           </a:bodyPr>
           <a:lstStyle/>
           <a:p>
-            <a:pPr>
-              <a:defRPr sz="4400" b="1">
-                <a:solidFill>
-                  <a:srgbClr val="1B2A4A"/>
-                </a:solidFill>
-              </a:defRPr>
+            <a:pPr algn="l">
+              <a:lnSpc>
+                <a:spcPct val="100000"/>
+              </a:lnSpc>
             </a:pPr>
             <a:r>
-              <a:t>LearnLoop: One Machine, Three Rooms</a:t>
-            </a:r>
-          </a:p>
-        </p:txBody>
-      </p:sp>
-      <p:sp>
-        <p:nvSpPr>
-          <p:cNvPr id="3" name="TextBox 2"/>
+              <a:rPr sz="1400" b="1" spc="300">
+                <a:solidFill>
+                  <a:srgbClr val="B9C2D6"/>
+                </a:solidFill>
+              </a:rPr>
+              <a:t>STUDYTUBE  ×  UNMUTED   ·   GTM AI WORKSHOP</a:t>
+            </a:r>
+          </a:p>
+        </p:txBody>
+      </p:sp>
+      <p:sp>
+        <p:nvSpPr>
+          <p:cNvPr id="6" name="TextBox 5"/>
           <p:cNvSpPr txBox="1"/>
           <p:nvPr/>
         </p:nvSpPr>
         <p:spPr>
           <a:xfrm>
-            <a:off x="731520" y="3657600"/>
-            <a:ext cx="10698480" cy="1097280"/>
+            <a:off x="804672" y="2331720"/>
+            <a:ext cx="11155680" cy="1645920"/>
           </a:xfrm>
           <a:prstGeom prst="rect">
             <a:avLst/>
@@ -3151,52 +3277,45 @@
           <a:noFill/>
         </p:spPr>
         <p:txBody>
-          <a:bodyPr wrap="none">
+          <a:bodyPr wrap="square">
             <a:spAutoFit/>
           </a:bodyPr>
           <a:lstStyle/>
           <a:p>
-            <a:pPr>
-              <a:defRPr sz="2000">
-                <a:solidFill>
-                  <a:srgbClr val="555B66"/>
-                </a:solidFill>
-              </a:defRPr>
+            <a:pPr algn="l">
+              <a:lnSpc>
+                <a:spcPct val="100000"/>
+              </a:lnSpc>
             </a:pPr>
             <a:r>
-              <a:t>Mentor briefing, GTM AI Workshop, Jul 16 2026. Mentor-only: this deck names the finale and the paths.</a:t>
-            </a:r>
-          </a:p>
-        </p:txBody>
-      </p:sp>
-    </p:spTree>
-  </p:cSld>
-  <p:clrMapOvr>
-    <a:masterClrMapping/>
-  </p:clrMapOvr>
-</p:sld>
-</file>
-
-<file path=ppt/slides/slide10.xml><?xml version="1.0" encoding="utf-8"?>
-<p:sld xmlns:a="http://schemas.openxmlformats.org/drawingml/2006/main" xmlns:p="http://schemas.openxmlformats.org/presentationml/2006/main" xmlns:r="http://schemas.openxmlformats.org/officeDocument/2006/relationships">
-  <p:cSld>
-    <p:spTree>
-      <p:nvGrpSpPr>
-        <p:cNvPr id="1" name=""/>
-        <p:cNvGrpSpPr/>
-        <p:nvPr/>
-      </p:nvGrpSpPr>
-      <p:grpSpPr/>
-      <p:sp>
-        <p:nvSpPr>
-          <p:cNvPr id="2" name="TextBox 1"/>
+              <a:rPr sz="9600" b="1">
+                <a:solidFill>
+                  <a:srgbClr val="FFFFFF"/>
+                </a:solidFill>
+              </a:rPr>
+              <a:t>LEARN</a:t>
+            </a:r>
+            <a:r>
+              <a:rPr sz="9600" b="1">
+                <a:solidFill>
+                  <a:srgbClr val="F05A28"/>
+                </a:solidFill>
+              </a:rPr>
+              <a:t>LOOP</a:t>
+            </a:r>
+          </a:p>
+        </p:txBody>
+      </p:sp>
+      <p:sp>
+        <p:nvSpPr>
+          <p:cNvPr id="7" name="TextBox 6"/>
           <p:cNvSpPr txBox="1"/>
           <p:nvPr/>
         </p:nvSpPr>
         <p:spPr>
           <a:xfrm>
-            <a:off x="731520" y="457200"/>
-            <a:ext cx="10698480" cy="914400"/>
+            <a:off x="868680" y="4160520"/>
+            <a:ext cx="10515600" cy="640080"/>
           </a:xfrm>
           <a:prstGeom prst="rect">
             <a:avLst/>
@@ -3204,34 +3323,37 @@
           <a:noFill/>
         </p:spPr>
         <p:txBody>
-          <a:bodyPr wrap="none">
+          <a:bodyPr wrap="square">
             <a:spAutoFit/>
           </a:bodyPr>
           <a:lstStyle/>
           <a:p>
-            <a:pPr>
-              <a:defRPr sz="3000" b="1">
-                <a:solidFill>
-                  <a:srgbClr val="1B2A4A"/>
-                </a:solidFill>
-              </a:defRPr>
+            <a:pPr algn="l">
+              <a:lnSpc>
+                <a:spcPct val="100000"/>
+              </a:lnSpc>
             </a:pPr>
             <a:r>
-              <a:t>What good looks like (the core of mentoring today)</a:t>
-            </a:r>
-          </a:p>
-        </p:txBody>
-      </p:sp>
-      <p:sp>
-        <p:nvSpPr>
-          <p:cNvPr id="3" name="TextBox 2"/>
+              <a:rPr sz="2600" b="0">
+                <a:solidFill>
+                  <a:srgbClr val="FFFFFF"/>
+                </a:solidFill>
+              </a:rPr>
+              <a:t>One machine, three rooms.</a:t>
+            </a:r>
+          </a:p>
+        </p:txBody>
+      </p:sp>
+      <p:sp>
+        <p:nvSpPr>
+          <p:cNvPr id="8" name="TextBox 7"/>
           <p:cNvSpPr txBox="1"/>
           <p:nvPr/>
         </p:nvSpPr>
         <p:spPr>
           <a:xfrm>
-            <a:off x="731520" y="1691640"/>
-            <a:ext cx="10698480" cy="4846320"/>
+            <a:off x="868680" y="5989320"/>
+            <a:ext cx="10515600" cy="457200"/>
           </a:xfrm>
           <a:prstGeom prst="rect">
             <a:avLst/>
@@ -3244,395 +3366,18 @@
           </a:bodyPr>
           <a:lstStyle/>
           <a:p>
-            <a:pPr>
-              <a:spcAft>
-                <a:spcPts val="700"/>
-              </a:spcAft>
-              <a:defRPr sz="1700" b="1">
-                <a:solidFill>
-                  <a:srgbClr val="1B2A4A"/>
-                </a:solidFill>
-              </a:defRPr>
+            <a:pPr algn="l">
+              <a:lnSpc>
+                <a:spcPct val="100000"/>
+              </a:lnSpc>
             </a:pPr>
             <a:r>
-              <a:t>•  1. Went through the assets. Not just the README: the send-log, the call notes, the corpus.</a:t>
-            </a:r>
-          </a:p>
-          <a:p>
-            <a:pPr>
-              <a:spcAft>
-                <a:spcPts val="700"/>
-              </a:spcAft>
-              <a:defRPr sz="1700" b="1">
-                <a:solidFill>
-                  <a:srgbClr val="1B2A4A"/>
-                </a:solidFill>
-              </a:defRPr>
-            </a:pPr>
-            <a:r>
-              <a:t>•  2. Identified a path. One clear read of the data, chosen among several possible.</a:t>
-            </a:r>
-          </a:p>
-          <a:p>
-            <a:pPr>
-              <a:spcAft>
-                <a:spcPts val="700"/>
-              </a:spcAft>
-              <a:defRPr sz="1700" b="1">
-                <a:solidFill>
-                  <a:srgbClr val="1B2A4A"/>
-                </a:solidFill>
-              </a:defRPr>
-            </a:pPr>
-            <a:r>
-              <a:t>•  3. Can reason about why. Evidence cited, counter-evidence acknowledged.</a:t>
-            </a:r>
-          </a:p>
-          <a:p>
-            <a:pPr>
-              <a:spcAft>
-                <a:spcPts val="700"/>
-              </a:spcAft>
-              <a:defRPr sz="1700" b="1">
-                <a:solidFill>
-                  <a:srgbClr val="1B2A4A"/>
-                </a:solidFill>
-              </a:defRPr>
-            </a:pPr>
-            <a:r>
-              <a:t>•  4. Built a solution around it. A running system shaped by that path, demoable.</a:t>
-            </a:r>
-          </a:p>
-          <a:p>
-            <a:pPr>
-              <a:spcAft>
-                <a:spcPts val="700"/>
-              </a:spcAft>
-              <a:defRPr sz="1700" b="0">
-                <a:solidFill>
-                  <a:srgbClr val="1B2A4A"/>
-                </a:solidFill>
-              </a:defRPr>
-            </a:pPr>
-            <a:r>
-              <a:t>•  There is no right answer and no answer brief. Grade the evidence trail, never the path choice.</a:t>
-            </a:r>
-          </a:p>
-          <a:p>
-            <a:pPr>
-              <a:spcAft>
-                <a:spcPts val="700"/>
-              </a:spcAft>
-              <a:defRPr sz="1700" b="0">
-                <a:solidFill>
-                  <a:srgbClr val="1B2A4A"/>
-                </a:solidFill>
-              </a:defRPr>
-            </a:pPr>
-            <a:r>
-              <a:t>•  A team disputing our own scaffolds (tiers, pod shortlist) with evidence is doing it exactly right.</a:t>
-            </a:r>
-          </a:p>
-        </p:txBody>
-      </p:sp>
-    </p:spTree>
-  </p:cSld>
-  <p:clrMapOvr>
-    <a:masterClrMapping/>
-  </p:clrMapOvr>
-</p:sld>
-</file>
-
-<file path=ppt/slides/slide11.xml><?xml version="1.0" encoding="utf-8"?>
-<p:sld xmlns:a="http://schemas.openxmlformats.org/drawingml/2006/main" xmlns:p="http://schemas.openxmlformats.org/presentationml/2006/main" xmlns:r="http://schemas.openxmlformats.org/officeDocument/2006/relationships">
-  <p:cSld>
-    <p:spTree>
-      <p:nvGrpSpPr>
-        <p:cNvPr id="1" name=""/>
-        <p:cNvGrpSpPr/>
-        <p:nvPr/>
-      </p:nvGrpSpPr>
-      <p:grpSpPr/>
-      <p:sp>
-        <p:nvSpPr>
-          <p:cNvPr id="2" name="TextBox 1"/>
-          <p:cNvSpPr txBox="1"/>
-          <p:nvPr/>
-        </p:nvSpPr>
-        <p:spPr>
-          <a:xfrm>
-            <a:off x="731520" y="457200"/>
-            <a:ext cx="10698480" cy="914400"/>
-          </a:xfrm>
-          <a:prstGeom prst="rect">
-            <a:avLst/>
-          </a:prstGeom>
-          <a:noFill/>
-        </p:spPr>
-        <p:txBody>
-          <a:bodyPr wrap="none">
-            <a:spAutoFit/>
-          </a:bodyPr>
-          <a:lstStyle/>
-          <a:p>
-            <a:pPr>
-              <a:defRPr sz="3000" b="1">
-                <a:solidFill>
-                  <a:srgbClr val="1B2A4A"/>
-                </a:solidFill>
-              </a:defRPr>
-            </a:pPr>
-            <a:r>
-              <a:t>Stuck teams: hint ladder (escalate gently, stop when they move)</a:t>
-            </a:r>
-          </a:p>
-        </p:txBody>
-      </p:sp>
-      <p:sp>
-        <p:nvSpPr>
-          <p:cNvPr id="3" name="TextBox 2"/>
-          <p:cNvSpPr txBox="1"/>
-          <p:nvPr/>
-        </p:nvSpPr>
-        <p:spPr>
-          <a:xfrm>
-            <a:off x="731520" y="1691640"/>
-            <a:ext cx="10698480" cy="4846320"/>
-          </a:xfrm>
-          <a:prstGeom prst="rect">
-            <a:avLst/>
-          </a:prstGeom>
-          <a:noFill/>
-        </p:spPr>
-        <p:txBody>
-          <a:bodyPr wrap="square">
-            <a:spAutoFit/>
-          </a:bodyPr>
-          <a:lstStyle/>
-          <a:p>
-            <a:pPr>
-              <a:spcAft>
-                <a:spcPts val="700"/>
-              </a:spcAft>
-              <a:defRPr sz="1700" b="1">
-                <a:solidFill>
-                  <a:srgbClr val="1B2A4A"/>
-                </a:solidFill>
-              </a:defRPr>
-            </a:pPr>
-            <a:r>
-              <a:t>•  H1 = a question. H2/H3 = point at an asset. H4 = direct. Full ladders per brief in paths-and-hints.md.</a:t>
-            </a:r>
-          </a:p>
-          <a:p>
-            <a:pPr>
-              <a:spcAft>
-                <a:spcPts val="700"/>
-              </a:spcAft>
-              <a:defRPr sz="1700" b="0">
-                <a:solidFill>
-                  <a:srgbClr val="1B2A4A"/>
-                </a:solidFill>
-              </a:defRPr>
-            </a:pPr>
-            <a:r>
-              <a:t>•  Brief 01: 'Which Monday-morning question does your system answer, and for whom?'</a:t>
-            </a:r>
-          </a:p>
-          <a:p>
-            <a:pPr>
-              <a:spcAft>
-                <a:spcPts val="700"/>
-              </a:spcAft>
-              <a:defRPr sz="1700" b="0">
-                <a:solidFill>
-                  <a:srgbClr val="1B2A4A"/>
-                </a:solidFill>
-              </a:defRPr>
-            </a:pPr>
-            <a:r>
-              <a:t>•  Brief 02: 'Run stack draft #8 through your checker. Zero banned words. Is it on-voice?'</a:t>
-            </a:r>
-          </a:p>
-          <a:p>
-            <a:pPr>
-              <a:spcAft>
-                <a:spcPts val="700"/>
-              </a:spcAft>
-              <a:defRPr sz="1700" b="0">
-                <a:solidFill>
-                  <a:srgbClr val="1B2A4A"/>
-                </a:solidFill>
-              </a:defRPr>
-            </a:pPr>
-            <a:r>
-              <a:t>•  Brief 03: 'Four people replied positively last quarter and nobody followed up. Found them yet?'</a:t>
-            </a:r>
-          </a:p>
-          <a:p>
-            <a:pPr>
-              <a:spcAft>
-                <a:spcPts val="700"/>
-              </a:spcAft>
-              <a:defRPr sz="1700" b="0">
-                <a:solidFill>
-                  <a:srgbClr val="1B2A4A"/>
-                </a:solidFill>
-              </a:defRPr>
-            </a:pPr>
-            <a:r>
-              <a:t>•  Never hand over a path. The find is the value.</a:t>
-            </a:r>
-          </a:p>
-        </p:txBody>
-      </p:sp>
-    </p:spTree>
-  </p:cSld>
-  <p:clrMapOvr>
-    <a:masterClrMapping/>
-  </p:clrMapOvr>
-</p:sld>
-</file>
-
-<file path=ppt/slides/slide12.xml><?xml version="1.0" encoding="utf-8"?>
-<p:sld xmlns:a="http://schemas.openxmlformats.org/drawingml/2006/main" xmlns:p="http://schemas.openxmlformats.org/presentationml/2006/main" xmlns:r="http://schemas.openxmlformats.org/officeDocument/2006/relationships">
-  <p:cSld>
-    <p:spTree>
-      <p:nvGrpSpPr>
-        <p:cNvPr id="1" name=""/>
-        <p:cNvGrpSpPr/>
-        <p:nvPr/>
-      </p:nvGrpSpPr>
-      <p:grpSpPr/>
-      <p:sp>
-        <p:nvSpPr>
-          <p:cNvPr id="2" name="TextBox 1"/>
-          <p:cNvSpPr txBox="1"/>
-          <p:nvPr/>
-        </p:nvSpPr>
-        <p:spPr>
-          <a:xfrm>
-            <a:off x="731520" y="457200"/>
-            <a:ext cx="10698480" cy="914400"/>
-          </a:xfrm>
-          <a:prstGeom prst="rect">
-            <a:avLst/>
-          </a:prstGeom>
-          <a:noFill/>
-        </p:spPr>
-        <p:txBody>
-          <a:bodyPr wrap="none">
-            <a:spAutoFit/>
-          </a:bodyPr>
-          <a:lstStyle/>
-          <a:p>
-            <a:pPr>
-              <a:defRPr sz="3000" b="1">
-                <a:solidFill>
-                  <a:srgbClr val="1B2A4A"/>
-                </a:solidFill>
-              </a:defRPr>
-            </a:pPr>
-            <a:r>
-              <a:t>The finale (mentor logistics, never announced early)</a:t>
-            </a:r>
-          </a:p>
-        </p:txBody>
-      </p:sp>
-      <p:sp>
-        <p:nvSpPr>
-          <p:cNvPr id="3" name="TextBox 2"/>
-          <p:cNvSpPr txBox="1"/>
-          <p:nvPr/>
-        </p:nvSpPr>
-        <p:spPr>
-          <a:xfrm>
-            <a:off x="731520" y="1691640"/>
-            <a:ext cx="10698480" cy="4846320"/>
-          </a:xfrm>
-          <a:prstGeom prst="rect">
-            <a:avLst/>
-          </a:prstGeom>
-          <a:noFill/>
-        </p:spPr>
-        <p:txBody>
-          <a:bodyPr wrap="square">
-            <a:spAutoFit/>
-          </a:bodyPr>
-          <a:lstStyle/>
-          <a:p>
-            <a:pPr>
-              <a:spcAft>
-                <a:spcPts val="700"/>
-              </a:spcAft>
-              <a:defRPr sz="1700" b="0">
-                <a:solidFill>
-                  <a:srgbClr val="1B2A4A"/>
-                </a:solidFill>
-              </a:defRPr>
-            </a:pPr>
-            <a:r>
-              <a:t>•  Build time ~2 hours. At T-47: two-minute warning, reveal nothing.</a:t>
-            </a:r>
-          </a:p>
-          <a:p>
-            <a:pPr>
-              <a:spcAft>
-                <a:spcPts val="700"/>
-              </a:spcAft>
-              <a:defRPr sz="1700" b="0">
-                <a:solidFill>
-                  <a:srgbClr val="1B2A4A"/>
-                </a:solidFill>
-              </a:defRPr>
-            </a:pPr>
-            <a:r>
-              <a:t>•  T-45: the curveball. Teams merge into cross-brief groups (5 teams: 3 + 2). Handover sheets from the runbook.</a:t>
-            </a:r>
-          </a:p>
-          <a:p>
-            <a:pPr>
-              <a:spcAft>
-                <a:spcPts val="700"/>
-              </a:spcAft>
-              <a:defRPr sz="1700" b="0">
-                <a:solidFill>
-                  <a:srgbClr val="1B2A4A"/>
-                </a:solidFill>
-              </a:defRPr>
-            </a:pPr>
-            <a:r>
-              <a:t>•  T-10: the chain-run, projected. One account travels SENSE to REACH to SPEAK to send.</a:t>
-            </a:r>
-          </a:p>
-          <a:p>
-            <a:pPr>
-              <a:spcAft>
-                <a:spcPts val="700"/>
-              </a:spcAft>
-              <a:defRPr sz="1700" b="0">
-                <a:solidFill>
-                  <a:srgbClr val="1B2A4A"/>
-                </a:solidFill>
-              </a:defRPr>
-            </a:pPr>
-            <a:r>
-              <a:t>•  T-0: demos, 3-4 min each, no slides. Room votes: closest to ship-ready.</a:t>
-            </a:r>
-          </a:p>
-          <a:p>
-            <a:pPr>
-              <a:spcAft>
-                <a:spcPts val="700"/>
-              </a:spcAft>
-              <a:defRPr sz="1700" b="1">
-                <a:solidFill>
-                  <a:srgbClr val="1B2A4A"/>
-                </a:solidFill>
-              </a:defRPr>
-            </a:pPr>
-            <a:r>
-              <a:t>•  Choreography, handover sheets, fallbacks: mentor-kit/close-the-loop-runbook.md</a:t>
+              <a:rPr sz="1300" b="0">
+                <a:solidFill>
+                  <a:srgbClr val="B9C2D6"/>
+                </a:solidFill>
+              </a:rPr>
+              <a:t>A fictional company with a very real problem   ·   16 July 2026</a:t>
             </a:r>
           </a:p>
         </p:txBody>
@@ -3657,14 +3402,102 @@
       <p:grpSpPr/>
       <p:sp>
         <p:nvSpPr>
-          <p:cNvPr id="2" name="TextBox 1"/>
+          <p:cNvPr id="2" name="Rectangle 1"/>
+          <p:cNvSpPr/>
+          <p:nvPr/>
+        </p:nvSpPr>
+        <p:spPr>
+          <a:xfrm>
+            <a:off x="0" y="0"/>
+            <a:ext cx="12191695" cy="6858000"/>
+          </a:xfrm>
+          <a:prstGeom prst="rect">
+            <a:avLst/>
+          </a:prstGeom>
+          <a:solidFill>
+            <a:srgbClr val="F6F4EF"/>
+          </a:solidFill>
+          <a:ln>
+            <a:noFill/>
+          </a:ln>
+          <a:effectLst/>
+        </p:spPr>
+        <p:style>
+          <a:lnRef idx="1">
+            <a:schemeClr val="accent1"/>
+          </a:lnRef>
+          <a:fillRef idx="3">
+            <a:schemeClr val="accent1"/>
+          </a:fillRef>
+          <a:effectRef idx="2">
+            <a:schemeClr val="accent1"/>
+          </a:effectRef>
+          <a:fontRef idx="minor">
+            <a:schemeClr val="lt1"/>
+          </a:fontRef>
+        </p:style>
+        <p:txBody>
+          <a:bodyPr rtlCol="0" anchor="ctr"/>
+          <a:lstStyle/>
+          <a:p>
+            <a:pPr algn="ctr"/>
+          </a:p>
+        </p:txBody>
+      </p:sp>
+      <p:sp>
+        <p:nvSpPr>
+          <p:cNvPr id="3" name="Rectangle 2"/>
+          <p:cNvSpPr/>
+          <p:nvPr/>
+        </p:nvSpPr>
+        <p:spPr>
+          <a:xfrm>
+            <a:off x="0" y="0"/>
+            <a:ext cx="164592" cy="6858000"/>
+          </a:xfrm>
+          <a:prstGeom prst="rect">
+            <a:avLst/>
+          </a:prstGeom>
+          <a:solidFill>
+            <a:srgbClr val="F05A28"/>
+          </a:solidFill>
+          <a:ln>
+            <a:noFill/>
+          </a:ln>
+          <a:effectLst/>
+        </p:spPr>
+        <p:style>
+          <a:lnRef idx="1">
+            <a:schemeClr val="accent1"/>
+          </a:lnRef>
+          <a:fillRef idx="3">
+            <a:schemeClr val="accent1"/>
+          </a:fillRef>
+          <a:effectRef idx="2">
+            <a:schemeClr val="accent1"/>
+          </a:effectRef>
+          <a:fontRef idx="minor">
+            <a:schemeClr val="lt1"/>
+          </a:fontRef>
+        </p:style>
+        <p:txBody>
+          <a:bodyPr rtlCol="0" anchor="ctr"/>
+          <a:lstStyle/>
+          <a:p>
+            <a:pPr algn="ctr"/>
+          </a:p>
+        </p:txBody>
+      </p:sp>
+      <p:sp>
+        <p:nvSpPr>
+          <p:cNvPr id="4" name="TextBox 3"/>
           <p:cNvSpPr txBox="1"/>
           <p:nvPr/>
         </p:nvSpPr>
         <p:spPr>
           <a:xfrm>
-            <a:off x="731520" y="457200"/>
-            <a:ext cx="10698480" cy="914400"/>
+            <a:off x="822960" y="411480"/>
+            <a:ext cx="10515600" cy="365760"/>
           </a:xfrm>
           <a:prstGeom prst="rect">
             <a:avLst/>
@@ -3672,34 +3505,37 @@
           <a:noFill/>
         </p:spPr>
         <p:txBody>
-          <a:bodyPr wrap="none">
+          <a:bodyPr wrap="square">
             <a:spAutoFit/>
           </a:bodyPr>
           <a:lstStyle/>
           <a:p>
-            <a:pPr>
-              <a:defRPr sz="3000" b="1">
-                <a:solidFill>
-                  <a:srgbClr val="1B2A4A"/>
-                </a:solidFill>
-              </a:defRPr>
+            <a:pPr algn="l">
+              <a:lnSpc>
+                <a:spcPct val="100000"/>
+              </a:lnSpc>
             </a:pPr>
             <a:r>
-              <a:t>The backstory, in 60 seconds</a:t>
-            </a:r>
-          </a:p>
-        </p:txBody>
-      </p:sp>
-      <p:sp>
-        <p:nvSpPr>
-          <p:cNvPr id="3" name="TextBox 2"/>
+              <a:rPr sz="1300" b="1" spc="300">
+                <a:solidFill>
+                  <a:srgbClr val="F05A28"/>
+                </a:solidFill>
+              </a:rPr>
+              <a:t>THE BACKSTORY</a:t>
+            </a:r>
+          </a:p>
+        </p:txBody>
+      </p:sp>
+      <p:sp>
+        <p:nvSpPr>
+          <p:cNvPr id="5" name="TextBox 4"/>
           <p:cNvSpPr txBox="1"/>
           <p:nvPr/>
         </p:nvSpPr>
         <p:spPr>
           <a:xfrm>
-            <a:off x="731520" y="1691640"/>
-            <a:ext cx="10698480" cy="4846320"/>
+            <a:off x="804672" y="777240"/>
+            <a:ext cx="10789920" cy="731520"/>
           </a:xfrm>
           <a:prstGeom prst="rect">
             <a:avLst/>
@@ -3712,78 +3548,662 @@
           </a:bodyPr>
           <a:lstStyle/>
           <a:p>
+            <a:pPr algn="l">
+              <a:lnSpc>
+                <a:spcPct val="100000"/>
+              </a:lnSpc>
+            </a:pPr>
+            <a:r>
+              <a:rPr sz="3200" b="1">
+                <a:solidFill>
+                  <a:srgbClr val="14213D"/>
+                </a:solidFill>
+              </a:rPr>
+              <a:t>A winning company that cannot afford its own growth</a:t>
+            </a:r>
+          </a:p>
+        </p:txBody>
+      </p:sp>
+      <p:sp>
+        <p:nvSpPr>
+          <p:cNvPr id="6" name="Rounded Rectangle 5"/>
+          <p:cNvSpPr/>
+          <p:nvPr/>
+        </p:nvSpPr>
+        <p:spPr>
+          <a:xfrm>
+            <a:off x="822960" y="1737360"/>
+            <a:ext cx="5358384" cy="2212848"/>
+          </a:xfrm>
+          <a:prstGeom prst="roundRect">
+            <a:avLst>
+              <a:gd name="adj" fmla="val 4500"/>
+            </a:avLst>
+          </a:prstGeom>
+          <a:solidFill>
+            <a:srgbClr val="FFFFFF"/>
+          </a:solidFill>
+          <a:ln>
+            <a:noFill/>
+          </a:ln>
+          <a:effectLst/>
+        </p:spPr>
+        <p:style>
+          <a:lnRef idx="1">
+            <a:schemeClr val="accent1"/>
+          </a:lnRef>
+          <a:fillRef idx="3">
+            <a:schemeClr val="accent1"/>
+          </a:fillRef>
+          <a:effectRef idx="2">
+            <a:schemeClr val="accent1"/>
+          </a:effectRef>
+          <a:fontRef idx="minor">
+            <a:schemeClr val="lt1"/>
+          </a:fontRef>
+        </p:style>
+        <p:txBody>
+          <a:bodyPr rtlCol="0" anchor="ctr"/>
+          <a:lstStyle/>
+          <a:p>
+            <a:pPr algn="ctr"/>
+          </a:p>
+        </p:txBody>
+      </p:sp>
+      <p:sp>
+        <p:nvSpPr>
+          <p:cNvPr id="7" name="Rectangle 6"/>
+          <p:cNvSpPr/>
+          <p:nvPr/>
+        </p:nvSpPr>
+        <p:spPr>
+          <a:xfrm>
+            <a:off x="1115568" y="2011680"/>
+            <a:ext cx="457200" cy="50800"/>
+          </a:xfrm>
+          <a:prstGeom prst="rect">
+            <a:avLst/>
+          </a:prstGeom>
+          <a:solidFill>
+            <a:srgbClr val="F05A28"/>
+          </a:solidFill>
+          <a:ln>
+            <a:noFill/>
+          </a:ln>
+          <a:effectLst/>
+        </p:spPr>
+        <p:style>
+          <a:lnRef idx="1">
+            <a:schemeClr val="accent1"/>
+          </a:lnRef>
+          <a:fillRef idx="3">
+            <a:schemeClr val="accent1"/>
+          </a:fillRef>
+          <a:effectRef idx="2">
+            <a:schemeClr val="accent1"/>
+          </a:effectRef>
+          <a:fontRef idx="minor">
+            <a:schemeClr val="lt1"/>
+          </a:fontRef>
+        </p:style>
+        <p:txBody>
+          <a:bodyPr rtlCol="0" anchor="ctr"/>
+          <a:lstStyle/>
+          <a:p>
+            <a:pPr algn="ctr"/>
+          </a:p>
+        </p:txBody>
+      </p:sp>
+      <p:sp>
+        <p:nvSpPr>
+          <p:cNvPr id="8" name="TextBox 7"/>
+          <p:cNvSpPr txBox="1"/>
+          <p:nvPr/>
+        </p:nvSpPr>
+        <p:spPr>
+          <a:xfrm>
+            <a:off x="1115568" y="2121408"/>
+            <a:ext cx="4773168" cy="1664208"/>
+          </a:xfrm>
+          <a:prstGeom prst="rect">
+            <a:avLst/>
+          </a:prstGeom>
+          <a:noFill/>
+        </p:spPr>
+        <p:txBody>
+          <a:bodyPr wrap="square">
+            <a:spAutoFit/>
+          </a:bodyPr>
+          <a:lstStyle/>
+          <a:p>
             <a:pPr>
-              <a:spcAft>
-                <a:spcPts val="700"/>
-              </a:spcAft>
-              <a:defRPr sz="1700" b="0">
-                <a:solidFill>
-                  <a:srgbClr val="1B2A4A"/>
+              <a:defRPr sz="1350" b="1">
+                <a:solidFill>
+                  <a:srgbClr val="14213D"/>
                 </a:solidFill>
               </a:defRPr>
             </a:pPr>
             <a:r>
-              <a:t>•  LearnLoop (fictional): B2B learning platform, Amsterdam, 2019. Promise: close the loop between learning and doing.</a:t>
-            </a:r>
-          </a:p>
-          <a:p>
-            <a:pPr>
-              <a:spcAft>
-                <a:spcPts val="700"/>
-              </a:spcAft>
-              <a:defRPr sz="1700" b="0">
-                <a:solidFill>
-                  <a:srgbClr val="1B2A4A"/>
+              <a:t>WHAT IT IS</a:t>
+            </a:r>
+          </a:p>
+          <a:p>
+            <a:pPr algn="l">
+              <a:lnSpc>
+                <a:spcPct val="108000"/>
+              </a:lnSpc>
+              <a:spcBef>
+                <a:spcPts val="500"/>
+              </a:spcBef>
+              <a:defRPr sz="1300" b="0">
+                <a:solidFill>
+                  <a:srgbClr val="5E6675"/>
                 </a:solidFill>
               </a:defRPr>
             </a:pPr>
             <a:r>
-              <a:t>•  It is WINNING: EUR 30M ARR, 55% growth, 750 customers, Series C. Board wants EUR 200M by 2030.</a:t>
-            </a:r>
-          </a:p>
-          <a:p>
-            <a:pPr>
-              <a:spcAft>
-                <a:spcPts val="700"/>
-              </a:spcAft>
-              <a:defRPr sz="1700" b="1">
-                <a:solidFill>
-                  <a:srgbClr val="1B2A4A"/>
+              <a:t>B2B learning platform, Amsterdam, 2019. Most tools prove your people finished the training. LearnLoop proves the skill landed.</a:t>
+            </a:r>
+          </a:p>
+          <a:p>
+            <a:pPr algn="l">
+              <a:lnSpc>
+                <a:spcPct val="108000"/>
+              </a:lnSpc>
+              <a:spcBef>
+                <a:spcPts val="800"/>
+              </a:spcBef>
+              <a:defRPr sz="1400" b="1">
+                <a:solidFill>
+                  <a:srgbClr val="F05A28"/>
                 </a:solidFill>
               </a:defRPr>
             </a:pPr>
             <a:r>
-              <a:t>•  The wall: the COST of growth. Every euro of pipeline still scales with headcount.</a:t>
-            </a:r>
-          </a:p>
-          <a:p>
-            <a:pPr lvl="1">
-              <a:spcAft>
-                <a:spcPts val="700"/>
-              </a:spcAft>
-              <a:defRPr sz="1450" b="0">
-                <a:solidFill>
-                  <a:srgbClr val="555B66"/>
+              <a:t>EUR 30M ARR  ·  55% growth  ·  750 customers</a:t>
+            </a:r>
+          </a:p>
+        </p:txBody>
+      </p:sp>
+      <p:sp>
+        <p:nvSpPr>
+          <p:cNvPr id="9" name="Rounded Rectangle 8"/>
+          <p:cNvSpPr/>
+          <p:nvPr/>
+        </p:nvSpPr>
+        <p:spPr>
+          <a:xfrm>
+            <a:off x="6364224" y="1737360"/>
+            <a:ext cx="5358384" cy="2212848"/>
+          </a:xfrm>
+          <a:prstGeom prst="roundRect">
+            <a:avLst>
+              <a:gd name="adj" fmla="val 4500"/>
+            </a:avLst>
+          </a:prstGeom>
+          <a:solidFill>
+            <a:srgbClr val="FFFFFF"/>
+          </a:solidFill>
+          <a:ln>
+            <a:noFill/>
+          </a:ln>
+          <a:effectLst/>
+        </p:spPr>
+        <p:style>
+          <a:lnRef idx="1">
+            <a:schemeClr val="accent1"/>
+          </a:lnRef>
+          <a:fillRef idx="3">
+            <a:schemeClr val="accent1"/>
+          </a:fillRef>
+          <a:effectRef idx="2">
+            <a:schemeClr val="accent1"/>
+          </a:effectRef>
+          <a:fontRef idx="minor">
+            <a:schemeClr val="lt1"/>
+          </a:fontRef>
+        </p:style>
+        <p:txBody>
+          <a:bodyPr rtlCol="0" anchor="ctr"/>
+          <a:lstStyle/>
+          <a:p>
+            <a:pPr algn="ctr"/>
+          </a:p>
+        </p:txBody>
+      </p:sp>
+      <p:sp>
+        <p:nvSpPr>
+          <p:cNvPr id="10" name="Rectangle 9"/>
+          <p:cNvSpPr/>
+          <p:nvPr/>
+        </p:nvSpPr>
+        <p:spPr>
+          <a:xfrm>
+            <a:off x="6656832" y="2011680"/>
+            <a:ext cx="457200" cy="50800"/>
+          </a:xfrm>
+          <a:prstGeom prst="rect">
+            <a:avLst/>
+          </a:prstGeom>
+          <a:solidFill>
+            <a:srgbClr val="F05A28"/>
+          </a:solidFill>
+          <a:ln>
+            <a:noFill/>
+          </a:ln>
+          <a:effectLst/>
+        </p:spPr>
+        <p:style>
+          <a:lnRef idx="1">
+            <a:schemeClr val="accent1"/>
+          </a:lnRef>
+          <a:fillRef idx="3">
+            <a:schemeClr val="accent1"/>
+          </a:fillRef>
+          <a:effectRef idx="2">
+            <a:schemeClr val="accent1"/>
+          </a:effectRef>
+          <a:fontRef idx="minor">
+            <a:schemeClr val="lt1"/>
+          </a:fontRef>
+        </p:style>
+        <p:txBody>
+          <a:bodyPr rtlCol="0" anchor="ctr"/>
+          <a:lstStyle/>
+          <a:p>
+            <a:pPr algn="ctr"/>
+          </a:p>
+        </p:txBody>
+      </p:sp>
+      <p:sp>
+        <p:nvSpPr>
+          <p:cNvPr id="11" name="TextBox 10"/>
+          <p:cNvSpPr txBox="1"/>
+          <p:nvPr/>
+        </p:nvSpPr>
+        <p:spPr>
+          <a:xfrm>
+            <a:off x="6656832" y="2121408"/>
+            <a:ext cx="4773168" cy="1664208"/>
+          </a:xfrm>
+          <a:prstGeom prst="rect">
+            <a:avLst/>
+          </a:prstGeom>
+          <a:noFill/>
+        </p:spPr>
+        <p:txBody>
+          <a:bodyPr wrap="square">
+            <a:spAutoFit/>
+          </a:bodyPr>
+          <a:lstStyle/>
+          <a:p>
+            <a:pPr>
+              <a:defRPr sz="1350" b="1">
+                <a:solidFill>
+                  <a:srgbClr val="14213D"/>
                 </a:solidFill>
               </a:defRPr>
             </a:pPr>
             <a:r>
-              <a:t>–  1 analyst reads 4 data sources nobody agrees on. 6 writers, voice drifting into generic filler. Warm network in Germany ran dry: 3,200 emails, 13 replies, 0.4%.</a:t>
-            </a:r>
-          </a:p>
-          <a:p>
-            <a:pPr>
-              <a:spcAft>
-                <a:spcPts val="700"/>
-              </a:spcAft>
-              <a:defRPr sz="1700" b="1">
-                <a:solidFill>
-                  <a:srgbClr val="1B2A4A"/>
+              <a:t>GROWING NEW MARKETS</a:t>
+            </a:r>
+          </a:p>
+          <a:p>
+            <a:pPr algn="l">
+              <a:lnSpc>
+                <a:spcPct val="108000"/>
+              </a:lnSpc>
+              <a:spcBef>
+                <a:spcPts val="500"/>
+              </a:spcBef>
+              <a:defRPr sz="1300" b="0">
+                <a:solidFill>
+                  <a:srgbClr val="5E6675"/>
                 </a:solidFill>
               </a:defRPr>
             </a:pPr>
             <a:r>
-              <a:t>•  Heads do not multiply. Systems do. Teams build the systems.</a:t>
+              <a:t>DACH first: a Berlin pod and 9 German logos, all won warm. Spain is next. The board wrote down a bigger number.</a:t>
+            </a:r>
+          </a:p>
+          <a:p>
+            <a:pPr algn="l">
+              <a:lnSpc>
+                <a:spcPct val="108000"/>
+              </a:lnSpc>
+              <a:spcBef>
+                <a:spcPts val="800"/>
+              </a:spcBef>
+              <a:defRPr sz="1400" b="1">
+                <a:solidFill>
+                  <a:srgbClr val="F05A28"/>
+                </a:solidFill>
+              </a:defRPr>
+            </a:pPr>
+            <a:r>
+              <a:t>EUR 200M ARR by 2030</a:t>
+            </a:r>
+          </a:p>
+        </p:txBody>
+      </p:sp>
+      <p:sp>
+        <p:nvSpPr>
+          <p:cNvPr id="12" name="Rounded Rectangle 11"/>
+          <p:cNvSpPr/>
+          <p:nvPr/>
+        </p:nvSpPr>
+        <p:spPr>
+          <a:xfrm>
+            <a:off x="822960" y="4133087"/>
+            <a:ext cx="5358384" cy="2212848"/>
+          </a:xfrm>
+          <a:prstGeom prst="roundRect">
+            <a:avLst>
+              <a:gd name="adj" fmla="val 4500"/>
+            </a:avLst>
+          </a:prstGeom>
+          <a:solidFill>
+            <a:srgbClr val="FFFFFF"/>
+          </a:solidFill>
+          <a:ln>
+            <a:noFill/>
+          </a:ln>
+          <a:effectLst/>
+        </p:spPr>
+        <p:style>
+          <a:lnRef idx="1">
+            <a:schemeClr val="accent1"/>
+          </a:lnRef>
+          <a:fillRef idx="3">
+            <a:schemeClr val="accent1"/>
+          </a:fillRef>
+          <a:effectRef idx="2">
+            <a:schemeClr val="accent1"/>
+          </a:effectRef>
+          <a:fontRef idx="minor">
+            <a:schemeClr val="lt1"/>
+          </a:fontRef>
+        </p:style>
+        <p:txBody>
+          <a:bodyPr rtlCol="0" anchor="ctr"/>
+          <a:lstStyle/>
+          <a:p>
+            <a:pPr algn="ctr"/>
+          </a:p>
+        </p:txBody>
+      </p:sp>
+      <p:sp>
+        <p:nvSpPr>
+          <p:cNvPr id="13" name="Rectangle 12"/>
+          <p:cNvSpPr/>
+          <p:nvPr/>
+        </p:nvSpPr>
+        <p:spPr>
+          <a:xfrm>
+            <a:off x="1115568" y="4407407"/>
+            <a:ext cx="457200" cy="50800"/>
+          </a:xfrm>
+          <a:prstGeom prst="rect">
+            <a:avLst/>
+          </a:prstGeom>
+          <a:solidFill>
+            <a:srgbClr val="F05A28"/>
+          </a:solidFill>
+          <a:ln>
+            <a:noFill/>
+          </a:ln>
+          <a:effectLst/>
+        </p:spPr>
+        <p:style>
+          <a:lnRef idx="1">
+            <a:schemeClr val="accent1"/>
+          </a:lnRef>
+          <a:fillRef idx="3">
+            <a:schemeClr val="accent1"/>
+          </a:fillRef>
+          <a:effectRef idx="2">
+            <a:schemeClr val="accent1"/>
+          </a:effectRef>
+          <a:fontRef idx="minor">
+            <a:schemeClr val="lt1"/>
+          </a:fontRef>
+        </p:style>
+        <p:txBody>
+          <a:bodyPr rtlCol="0" anchor="ctr"/>
+          <a:lstStyle/>
+          <a:p>
+            <a:pPr algn="ctr"/>
+          </a:p>
+        </p:txBody>
+      </p:sp>
+      <p:sp>
+        <p:nvSpPr>
+          <p:cNvPr id="14" name="TextBox 13"/>
+          <p:cNvSpPr txBox="1"/>
+          <p:nvPr/>
+        </p:nvSpPr>
+        <p:spPr>
+          <a:xfrm>
+            <a:off x="1115568" y="4517135"/>
+            <a:ext cx="4773168" cy="1664208"/>
+          </a:xfrm>
+          <a:prstGeom prst="rect">
+            <a:avLst/>
+          </a:prstGeom>
+          <a:noFill/>
+        </p:spPr>
+        <p:txBody>
+          <a:bodyPr wrap="square">
+            <a:spAutoFit/>
+          </a:bodyPr>
+          <a:lstStyle/>
+          <a:p>
+            <a:pPr>
+              <a:defRPr sz="1350" b="1">
+                <a:solidFill>
+                  <a:srgbClr val="14213D"/>
+                </a:solidFill>
+              </a:defRPr>
+            </a:pPr>
+            <a:r>
+              <a:t>THE STRATEGY WORKS</a:t>
+            </a:r>
+          </a:p>
+          <a:p>
+            <a:pPr algn="l">
+              <a:lnSpc>
+                <a:spcPct val="108000"/>
+              </a:lnSpc>
+              <a:spcBef>
+                <a:spcPts val="500"/>
+              </a:spcBef>
+              <a:defRPr sz="1300" b="0">
+                <a:solidFill>
+                  <a:srgbClr val="5E6675"/>
+                </a:solidFill>
+              </a:defRPr>
+            </a:pPr>
+            <a:r>
+              <a:t>The product wins deals. Customers renew. The pitch lands. Nobody in this story is failing; this is not a turnaround.</a:t>
+            </a:r>
+          </a:p>
+          <a:p>
+            <a:pPr algn="l">
+              <a:lnSpc>
+                <a:spcPct val="108000"/>
+              </a:lnSpc>
+              <a:spcBef>
+                <a:spcPts val="800"/>
+              </a:spcBef>
+              <a:defRPr sz="1400" b="1">
+                <a:solidFill>
+                  <a:srgbClr val="F05A28"/>
+                </a:solidFill>
+              </a:defRPr>
+            </a:pPr>
+            <a:r>
+              <a:t>The playbook is right. It lives in 6 heads.</a:t>
+            </a:r>
+          </a:p>
+        </p:txBody>
+      </p:sp>
+      <p:sp>
+        <p:nvSpPr>
+          <p:cNvPr id="15" name="Rounded Rectangle 14"/>
+          <p:cNvSpPr/>
+          <p:nvPr/>
+        </p:nvSpPr>
+        <p:spPr>
+          <a:xfrm>
+            <a:off x="6364224" y="4133087"/>
+            <a:ext cx="5358384" cy="2212848"/>
+          </a:xfrm>
+          <a:prstGeom prst="roundRect">
+            <a:avLst>
+              <a:gd name="adj" fmla="val 4500"/>
+            </a:avLst>
+          </a:prstGeom>
+          <a:solidFill>
+            <a:srgbClr val="FFFFFF"/>
+          </a:solidFill>
+          <a:ln>
+            <a:noFill/>
+          </a:ln>
+          <a:effectLst/>
+        </p:spPr>
+        <p:style>
+          <a:lnRef idx="1">
+            <a:schemeClr val="accent1"/>
+          </a:lnRef>
+          <a:fillRef idx="3">
+            <a:schemeClr val="accent1"/>
+          </a:fillRef>
+          <a:effectRef idx="2">
+            <a:schemeClr val="accent1"/>
+          </a:effectRef>
+          <a:fontRef idx="minor">
+            <a:schemeClr val="lt1"/>
+          </a:fontRef>
+        </p:style>
+        <p:txBody>
+          <a:bodyPr rtlCol="0" anchor="ctr"/>
+          <a:lstStyle/>
+          <a:p>
+            <a:pPr algn="ctr"/>
+          </a:p>
+        </p:txBody>
+      </p:sp>
+      <p:sp>
+        <p:nvSpPr>
+          <p:cNvPr id="16" name="Rectangle 15"/>
+          <p:cNvSpPr/>
+          <p:nvPr/>
+        </p:nvSpPr>
+        <p:spPr>
+          <a:xfrm>
+            <a:off x="6656832" y="4407407"/>
+            <a:ext cx="457200" cy="50800"/>
+          </a:xfrm>
+          <a:prstGeom prst="rect">
+            <a:avLst/>
+          </a:prstGeom>
+          <a:solidFill>
+            <a:srgbClr val="F05A28"/>
+          </a:solidFill>
+          <a:ln>
+            <a:noFill/>
+          </a:ln>
+          <a:effectLst/>
+        </p:spPr>
+        <p:style>
+          <a:lnRef idx="1">
+            <a:schemeClr val="accent1"/>
+          </a:lnRef>
+          <a:fillRef idx="3">
+            <a:schemeClr val="accent1"/>
+          </a:fillRef>
+          <a:effectRef idx="2">
+            <a:schemeClr val="accent1"/>
+          </a:effectRef>
+          <a:fontRef idx="minor">
+            <a:schemeClr val="lt1"/>
+          </a:fontRef>
+        </p:style>
+        <p:txBody>
+          <a:bodyPr rtlCol="0" anchor="ctr"/>
+          <a:lstStyle/>
+          <a:p>
+            <a:pPr algn="ctr"/>
+          </a:p>
+        </p:txBody>
+      </p:sp>
+      <p:sp>
+        <p:nvSpPr>
+          <p:cNvPr id="17" name="TextBox 16"/>
+          <p:cNvSpPr txBox="1"/>
+          <p:nvPr/>
+        </p:nvSpPr>
+        <p:spPr>
+          <a:xfrm>
+            <a:off x="6656832" y="4517135"/>
+            <a:ext cx="4773168" cy="1664208"/>
+          </a:xfrm>
+          <a:prstGeom prst="rect">
+            <a:avLst/>
+          </a:prstGeom>
+          <a:noFill/>
+        </p:spPr>
+        <p:txBody>
+          <a:bodyPr wrap="square">
+            <a:spAutoFit/>
+          </a:bodyPr>
+          <a:lstStyle/>
+          <a:p>
+            <a:pPr>
+              <a:defRPr sz="1350" b="1">
+                <a:solidFill>
+                  <a:srgbClr val="14213D"/>
+                </a:solidFill>
+              </a:defRPr>
+            </a:pPr>
+            <a:r>
+              <a:t>A SYSTEM IS NEEDED</a:t>
+            </a:r>
+          </a:p>
+          <a:p>
+            <a:pPr algn="l">
+              <a:lnSpc>
+                <a:spcPct val="108000"/>
+              </a:lnSpc>
+              <a:spcBef>
+                <a:spcPts val="500"/>
+              </a:spcBef>
+              <a:defRPr sz="1300" b="0">
+                <a:solidFill>
+                  <a:srgbClr val="5E6675"/>
+                </a:solidFill>
+              </a:defRPr>
+            </a:pPr>
+            <a:r>
+              <a:t>Every euro of pipeline still scales with headcount. When the warm network ran dry, templates took over.</a:t>
+            </a:r>
+          </a:p>
+          <a:p>
+            <a:pPr algn="l">
+              <a:lnSpc>
+                <a:spcPct val="108000"/>
+              </a:lnSpc>
+              <a:spcBef>
+                <a:spcPts val="800"/>
+              </a:spcBef>
+              <a:defRPr sz="1400" b="1">
+                <a:solidFill>
+                  <a:srgbClr val="F05A28"/>
+                </a:solidFill>
+              </a:defRPr>
+            </a:pPr>
+            <a:r>
+              <a:t>3,200 emails  ·  13 replies  ·  0.4%</a:t>
             </a:r>
           </a:p>
         </p:txBody>
@@ -3808,14 +4228,102 @@
       <p:grpSpPr/>
       <p:sp>
         <p:nvSpPr>
-          <p:cNvPr id="2" name="TextBox 1"/>
+          <p:cNvPr id="2" name="Rectangle 1"/>
+          <p:cNvSpPr/>
+          <p:nvPr/>
+        </p:nvSpPr>
+        <p:spPr>
+          <a:xfrm>
+            <a:off x="0" y="0"/>
+            <a:ext cx="12191695" cy="6858000"/>
+          </a:xfrm>
+          <a:prstGeom prst="rect">
+            <a:avLst/>
+          </a:prstGeom>
+          <a:solidFill>
+            <a:srgbClr val="F6F4EF"/>
+          </a:solidFill>
+          <a:ln>
+            <a:noFill/>
+          </a:ln>
+          <a:effectLst/>
+        </p:spPr>
+        <p:style>
+          <a:lnRef idx="1">
+            <a:schemeClr val="accent1"/>
+          </a:lnRef>
+          <a:fillRef idx="3">
+            <a:schemeClr val="accent1"/>
+          </a:fillRef>
+          <a:effectRef idx="2">
+            <a:schemeClr val="accent1"/>
+          </a:effectRef>
+          <a:fontRef idx="minor">
+            <a:schemeClr val="lt1"/>
+          </a:fontRef>
+        </p:style>
+        <p:txBody>
+          <a:bodyPr rtlCol="0" anchor="ctr"/>
+          <a:lstStyle/>
+          <a:p>
+            <a:pPr algn="ctr"/>
+          </a:p>
+        </p:txBody>
+      </p:sp>
+      <p:sp>
+        <p:nvSpPr>
+          <p:cNvPr id="3" name="Rectangle 2"/>
+          <p:cNvSpPr/>
+          <p:nvPr/>
+        </p:nvSpPr>
+        <p:spPr>
+          <a:xfrm>
+            <a:off x="0" y="0"/>
+            <a:ext cx="164592" cy="6858000"/>
+          </a:xfrm>
+          <a:prstGeom prst="rect">
+            <a:avLst/>
+          </a:prstGeom>
+          <a:solidFill>
+            <a:srgbClr val="F05A28"/>
+          </a:solidFill>
+          <a:ln>
+            <a:noFill/>
+          </a:ln>
+          <a:effectLst/>
+        </p:spPr>
+        <p:style>
+          <a:lnRef idx="1">
+            <a:schemeClr val="accent1"/>
+          </a:lnRef>
+          <a:fillRef idx="3">
+            <a:schemeClr val="accent1"/>
+          </a:fillRef>
+          <a:effectRef idx="2">
+            <a:schemeClr val="accent1"/>
+          </a:effectRef>
+          <a:fontRef idx="minor">
+            <a:schemeClr val="lt1"/>
+          </a:fontRef>
+        </p:style>
+        <p:txBody>
+          <a:bodyPr rtlCol="0" anchor="ctr"/>
+          <a:lstStyle/>
+          <a:p>
+            <a:pPr algn="ctr"/>
+          </a:p>
+        </p:txBody>
+      </p:sp>
+      <p:sp>
+        <p:nvSpPr>
+          <p:cNvPr id="4" name="TextBox 3"/>
           <p:cNvSpPr txBox="1"/>
           <p:nvPr/>
         </p:nvSpPr>
         <p:spPr>
           <a:xfrm>
-            <a:off x="731520" y="457200"/>
-            <a:ext cx="10698480" cy="914400"/>
+            <a:off x="822960" y="411480"/>
+            <a:ext cx="10515600" cy="365760"/>
           </a:xfrm>
           <a:prstGeom prst="rect">
             <a:avLst/>
@@ -3823,34 +4331,37 @@
           <a:noFill/>
         </p:spPr>
         <p:txBody>
-          <a:bodyPr wrap="none">
+          <a:bodyPr wrap="square">
             <a:spAutoFit/>
           </a:bodyPr>
           <a:lstStyle/>
           <a:p>
-            <a:pPr>
-              <a:defRPr sz="3000" b="1">
-                <a:solidFill>
-                  <a:srgbClr val="1B2A4A"/>
-                </a:solidFill>
-              </a:defRPr>
+            <a:pPr algn="l">
+              <a:lnSpc>
+                <a:spcPct val="100000"/>
+              </a:lnSpc>
             </a:pPr>
             <a:r>
-              <a:t>One machine, three briefs (assigned, not chosen)</a:t>
-            </a:r>
-          </a:p>
-        </p:txBody>
-      </p:sp>
-      <p:sp>
-        <p:nvSpPr>
-          <p:cNvPr id="3" name="TextBox 2"/>
+              <a:rPr sz="1300" b="1" spc="300">
+                <a:solidFill>
+                  <a:srgbClr val="F05A28"/>
+                </a:solidFill>
+              </a:rPr>
+              <a:t>THE BRIEFS</a:t>
+            </a:r>
+          </a:p>
+        </p:txBody>
+      </p:sp>
+      <p:sp>
+        <p:nvSpPr>
+          <p:cNvPr id="5" name="TextBox 4"/>
           <p:cNvSpPr txBox="1"/>
           <p:nvPr/>
         </p:nvSpPr>
         <p:spPr>
           <a:xfrm>
-            <a:off x="731520" y="1691640"/>
-            <a:ext cx="10698480" cy="4846320"/>
+            <a:off x="804672" y="777240"/>
+            <a:ext cx="10789920" cy="731520"/>
           </a:xfrm>
           <a:prstGeom prst="rect">
             <a:avLst/>
@@ -3863,110 +4374,78 @@
           </a:bodyPr>
           <a:lstStyle/>
           <a:p>
-            <a:pPr>
-              <a:spcAft>
-                <a:spcPts val="700"/>
-              </a:spcAft>
-              <a:defRPr sz="1700" b="0">
-                <a:solidFill>
-                  <a:srgbClr val="1B2A4A"/>
-                </a:solidFill>
-              </a:defRPr>
+            <a:pPr algn="l">
+              <a:lnSpc>
+                <a:spcPct val="100000"/>
+              </a:lnSpc>
             </a:pPr>
             <a:r>
-              <a:t>•  Brief 01, The Signal Room = SENSE: who do we reach out to, why now, what is the hook?</a:t>
-            </a:r>
-          </a:p>
-          <a:p>
-            <a:pPr>
-              <a:spcAft>
-                <a:spcPts val="700"/>
-              </a:spcAft>
-              <a:defRPr sz="1700" b="0">
-                <a:solidFill>
-                  <a:srgbClr val="1B2A4A"/>
-                </a:solidFill>
-              </a:defRPr>
-            </a:pPr>
-            <a:r>
-              <a:t>•  Brief 02, The Brand Voice Machine = SPEAK: brief in, on-voice asset out, across EN/DE/ES.</a:t>
-            </a:r>
-          </a:p>
-          <a:p>
-            <a:pPr>
-              <a:spcAft>
-                <a:spcPts val="700"/>
-              </a:spcAft>
-              <a:defRPr sz="1700" b="0">
-                <a:solidFill>
-                  <a:srgbClr val="1B2A4A"/>
-                </a:solidFill>
-              </a:defRPr>
-            </a:pPr>
-            <a:r>
-              <a:t>•  Brief 03, The Account Penetration Machine = REACH: prioritized account in, distribution play out.</a:t>
-            </a:r>
-          </a:p>
-          <a:p>
-            <a:pPr>
-              <a:spcAft>
-                <a:spcPts val="700"/>
-              </a:spcAft>
-              <a:defRPr sz="1700" b="0">
-                <a:solidFill>
-                  <a:srgbClr val="1B2A4A"/>
-                </a:solidFill>
-              </a:defRPr>
-            </a:pPr>
-            <a:r>
-              <a:t>•  Each brief is standalone and judged standalone. The packs only hint: 'it is a full system.'</a:t>
-            </a:r>
-          </a:p>
-          <a:p>
-            <a:pPr>
-              <a:spcAft>
-                <a:spcPts val="700"/>
-              </a:spcAft>
-              <a:defRPr sz="1700" b="1">
-                <a:solidFill>
-                  <a:srgbClr val="1B2A4A"/>
-                </a:solidFill>
-              </a:defRPr>
-            </a:pPr>
-            <a:r>
-              <a:t>•  MENTOR-ONLY: at T-45 the reconnect is announced as a curveball. Never mention it before.</a:t>
-            </a:r>
-          </a:p>
-        </p:txBody>
-      </p:sp>
-    </p:spTree>
-  </p:cSld>
-  <p:clrMapOvr>
-    <a:masterClrMapping/>
-  </p:clrMapOvr>
-</p:sld>
-</file>
-
-<file path=ppt/slides/slide4.xml><?xml version="1.0" encoding="utf-8"?>
-<p:sld xmlns:a="http://schemas.openxmlformats.org/drawingml/2006/main" xmlns:p="http://schemas.openxmlformats.org/presentationml/2006/main" xmlns:r="http://schemas.openxmlformats.org/officeDocument/2006/relationships">
-  <p:cSld>
-    <p:spTree>
-      <p:nvGrpSpPr>
-        <p:cNvPr id="1" name=""/>
-        <p:cNvGrpSpPr/>
-        <p:nvPr/>
-      </p:nvGrpSpPr>
-      <p:grpSpPr/>
-      <p:sp>
-        <p:nvSpPr>
-          <p:cNvPr id="2" name="TextBox 1"/>
+              <a:rPr sz="3200" b="1">
+                <a:solidFill>
+                  <a:srgbClr val="14213D"/>
+                </a:solidFill>
+              </a:rPr>
+              <a:t>Great GTM runs on three skills. Build them as machines.</a:t>
+            </a:r>
+          </a:p>
+        </p:txBody>
+      </p:sp>
+      <p:sp>
+        <p:nvSpPr>
+          <p:cNvPr id="6" name="Rounded Rectangle 5"/>
+          <p:cNvSpPr/>
+          <p:nvPr/>
+        </p:nvSpPr>
+        <p:spPr>
+          <a:xfrm>
+            <a:off x="822960" y="1783080"/>
+            <a:ext cx="3529584" cy="3977639"/>
+          </a:xfrm>
+          <a:prstGeom prst="roundRect">
+            <a:avLst>
+              <a:gd name="adj" fmla="val 3000"/>
+            </a:avLst>
+          </a:prstGeom>
+          <a:solidFill>
+            <a:srgbClr val="1C2D52"/>
+          </a:solidFill>
+          <a:ln>
+            <a:noFill/>
+          </a:ln>
+          <a:effectLst/>
+        </p:spPr>
+        <p:style>
+          <a:lnRef idx="1">
+            <a:schemeClr val="accent1"/>
+          </a:lnRef>
+          <a:fillRef idx="3">
+            <a:schemeClr val="accent1"/>
+          </a:fillRef>
+          <a:effectRef idx="2">
+            <a:schemeClr val="accent1"/>
+          </a:effectRef>
+          <a:fontRef idx="minor">
+            <a:schemeClr val="lt1"/>
+          </a:fontRef>
+        </p:style>
+        <p:txBody>
+          <a:bodyPr rtlCol="0" anchor="ctr"/>
+          <a:lstStyle/>
+          <a:p>
+            <a:pPr algn="ctr"/>
+          </a:p>
+        </p:txBody>
+      </p:sp>
+      <p:sp>
+        <p:nvSpPr>
+          <p:cNvPr id="7" name="TextBox 6"/>
           <p:cNvSpPr txBox="1"/>
           <p:nvPr/>
         </p:nvSpPr>
         <p:spPr>
           <a:xfrm>
-            <a:off x="731520" y="457200"/>
-            <a:ext cx="10698480" cy="914400"/>
+            <a:off x="1133856" y="2039112"/>
+            <a:ext cx="2907792" cy="3465575"/>
           </a:xfrm>
           <a:prstGeom prst="rect">
             <a:avLst/>
@@ -3974,34 +4453,158 @@
           <a:noFill/>
         </p:spPr>
         <p:txBody>
-          <a:bodyPr wrap="none">
+          <a:bodyPr wrap="square">
             <a:spAutoFit/>
           </a:bodyPr>
           <a:lstStyle/>
           <a:p>
-            <a:pPr>
-              <a:defRPr sz="3000" b="1">
-                <a:solidFill>
-                  <a:srgbClr val="1B2A4A"/>
+            <a:r>
+              <a:rPr sz="3400" b="1">
+                <a:solidFill>
+                  <a:srgbClr val="F05A28"/>
+                </a:solidFill>
+              </a:rPr>
+              <a:t>01  </a:t>
+            </a:r>
+            <a:r>
+              <a:rPr sz="1600" b="1">
+                <a:solidFill>
+                  <a:srgbClr val="B9C2D6"/>
+                </a:solidFill>
+              </a:rPr>
+              <a:t>SENSE</a:t>
+            </a:r>
+          </a:p>
+          <a:p>
+            <a:pPr algn="l">
+              <a:lnSpc>
+                <a:spcPct val="108000"/>
+              </a:lnSpc>
+              <a:spcBef>
+                <a:spcPts val="200"/>
+              </a:spcBef>
+              <a:defRPr sz="1900" b="1">
+                <a:solidFill>
+                  <a:srgbClr val="FFFFFF"/>
                 </a:solidFill>
               </a:defRPr>
             </a:pPr>
             <a:r>
-              <a:t>Brief 01: The Signal Room (SENSE)</a:t>
-            </a:r>
-          </a:p>
-        </p:txBody>
-      </p:sp>
-      <p:sp>
-        <p:nvSpPr>
-          <p:cNvPr id="3" name="TextBox 2"/>
+              <a:t>The Signal Room</a:t>
+            </a:r>
+          </a:p>
+          <a:p>
+            <a:pPr algn="l">
+              <a:lnSpc>
+                <a:spcPct val="108000"/>
+              </a:lnSpc>
+              <a:spcBef>
+                <a:spcPts val="1000"/>
+              </a:spcBef>
+              <a:defRPr sz="1250" b="0">
+                <a:solidFill>
+                  <a:srgbClr val="B9C2D6"/>
+                </a:solidFill>
+              </a:defRPr>
+            </a:pPr>
+            <a:r>
+              <a:t>The market emits signals; nobody is catching them.</a:t>
+            </a:r>
+          </a:p>
+          <a:p>
+            <a:pPr algn="l">
+              <a:lnSpc>
+                <a:spcPct val="108000"/>
+              </a:lnSpc>
+              <a:spcBef>
+                <a:spcPts val="1400"/>
+              </a:spcBef>
+              <a:defRPr sz="1050" b="1">
+                <a:solidFill>
+                  <a:srgbClr val="F05A28"/>
+                </a:solidFill>
+              </a:defRPr>
+            </a:pPr>
+            <a:r>
+              <a:t>YOU BUILD</a:t>
+            </a:r>
+          </a:p>
+          <a:p>
+            <a:pPr algn="l">
+              <a:lnSpc>
+                <a:spcPct val="108000"/>
+              </a:lnSpc>
+              <a:spcBef>
+                <a:spcPts val="300"/>
+              </a:spcBef>
+              <a:defRPr sz="1350" b="0">
+                <a:solidFill>
+                  <a:srgbClr val="FFFFFF"/>
+                </a:solidFill>
+              </a:defRPr>
+            </a:pPr>
+            <a:r>
+              <a:t>A system that decides: which of the 50 accounts do we reach out to, why now, and with what hook.</a:t>
+            </a:r>
+          </a:p>
+        </p:txBody>
+      </p:sp>
+      <p:sp>
+        <p:nvSpPr>
+          <p:cNvPr id="8" name="Rounded Rectangle 7"/>
+          <p:cNvSpPr/>
+          <p:nvPr/>
+        </p:nvSpPr>
+        <p:spPr>
+          <a:xfrm>
+            <a:off x="4636008" y="1783080"/>
+            <a:ext cx="3529584" cy="3977639"/>
+          </a:xfrm>
+          <a:prstGeom prst="roundRect">
+            <a:avLst>
+              <a:gd name="adj" fmla="val 3000"/>
+            </a:avLst>
+          </a:prstGeom>
+          <a:solidFill>
+            <a:srgbClr val="1C2D52"/>
+          </a:solidFill>
+          <a:ln>
+            <a:noFill/>
+          </a:ln>
+          <a:effectLst/>
+        </p:spPr>
+        <p:style>
+          <a:lnRef idx="1">
+            <a:schemeClr val="accent1"/>
+          </a:lnRef>
+          <a:fillRef idx="3">
+            <a:schemeClr val="accent1"/>
+          </a:fillRef>
+          <a:effectRef idx="2">
+            <a:schemeClr val="accent1"/>
+          </a:effectRef>
+          <a:fontRef idx="minor">
+            <a:schemeClr val="lt1"/>
+          </a:fontRef>
+        </p:style>
+        <p:txBody>
+          <a:bodyPr rtlCol="0" anchor="ctr"/>
+          <a:lstStyle/>
+          <a:p>
+            <a:pPr algn="ctr"/>
+          </a:p>
+        </p:txBody>
+      </p:sp>
+      <p:sp>
+        <p:nvSpPr>
+          <p:cNvPr id="9" name="TextBox 8"/>
           <p:cNvSpPr txBox="1"/>
           <p:nvPr/>
         </p:nvSpPr>
         <p:spPr>
           <a:xfrm>
-            <a:off x="731520" y="1691640"/>
-            <a:ext cx="10698480" cy="4846320"/>
+            <a:off x="4946904" y="2039112"/>
+            <a:ext cx="2907792" cy="3465575"/>
           </a:xfrm>
           <a:prstGeom prst="rect">
             <a:avLst/>
@@ -4014,95 +4617,153 @@
           </a:bodyPr>
           <a:lstStyle/>
           <a:p>
-            <a:pPr>
-              <a:spcAft>
-                <a:spcPts val="700"/>
-              </a:spcAft>
-              <a:defRPr sz="1700" b="0">
-                <a:solidFill>
-                  <a:srgbClr val="1B2A4A"/>
+            <a:r>
+              <a:rPr sz="3400" b="1">
+                <a:solidFill>
+                  <a:srgbClr val="F05A28"/>
+                </a:solidFill>
+              </a:rPr>
+              <a:t>02  </a:t>
+            </a:r>
+            <a:r>
+              <a:rPr sz="1600" b="1">
+                <a:solidFill>
+                  <a:srgbClr val="B9C2D6"/>
+                </a:solidFill>
+              </a:rPr>
+              <a:t>SPEAK</a:t>
+            </a:r>
+          </a:p>
+          <a:p>
+            <a:pPr algn="l">
+              <a:lnSpc>
+                <a:spcPct val="108000"/>
+              </a:lnSpc>
+              <a:spcBef>
+                <a:spcPts val="200"/>
+              </a:spcBef>
+              <a:defRPr sz="1900" b="1">
+                <a:solidFill>
+                  <a:srgbClr val="FFFFFF"/>
                 </a:solidFill>
               </a:defRPr>
             </a:pPr>
             <a:r>
-              <a:t>•  Build: a system that identifies and prioritizes accounts. Who, why now, what hook.</a:t>
-            </a:r>
-          </a:p>
-          <a:p>
-            <a:pPr>
-              <a:spcAft>
-                <a:spcPts val="700"/>
-              </a:spcAft>
-              <a:defRPr sz="1700" b="0">
-                <a:solidFill>
-                  <a:srgbClr val="1B2A4A"/>
+              <a:t>The Brand Voice Machine</a:t>
+            </a:r>
+          </a:p>
+          <a:p>
+            <a:pPr algn="l">
+              <a:lnSpc>
+                <a:spcPct val="108000"/>
+              </a:lnSpc>
+              <a:spcBef>
+                <a:spcPts val="1000"/>
+              </a:spcBef>
+              <a:defRPr sz="1250" b="0">
+                <a:solidFill>
+                  <a:srgbClr val="B9C2D6"/>
                 </a:solidFill>
               </a:defRPr>
             </a:pPr>
             <a:r>
-              <a:t>•  Data: 50 DACH accounts, a noisy market feed, contact signals, and 4 messy internal sources for calibration.</a:t>
-            </a:r>
-          </a:p>
-          <a:p>
-            <a:pPr>
-              <a:spcAft>
-                <a:spcPts val="700"/>
-              </a:spcAft>
-              <a:defRPr sz="1700" b="0">
-                <a:solidFill>
-                  <a:srgbClr val="1B2A4A"/>
+              <a:t>Six authors, three languages, a voice drifting into filler.</a:t>
+            </a:r>
+          </a:p>
+          <a:p>
+            <a:pPr algn="l">
+              <a:lnSpc>
+                <a:spcPct val="108000"/>
+              </a:lnSpc>
+              <a:spcBef>
+                <a:spcPts val="1400"/>
+              </a:spcBef>
+              <a:defRPr sz="1050" b="1">
+                <a:solidFill>
+                  <a:srgbClr val="F05A28"/>
                 </a:solidFill>
               </a:defRPr>
             </a:pPr>
             <a:r>
-              <a:t>•  Winning demo: feed it a fresh signal, ask 'who moved up and why', and let the room interrogate any ranking.</a:t>
-            </a:r>
-          </a:p>
-          <a:p>
-            <a:pPr>
-              <a:spcAft>
-                <a:spcPts val="700"/>
-              </a:spcAft>
-              <a:defRPr sz="1700" b="1">
-                <a:solidFill>
-                  <a:srgbClr val="1B2A4A"/>
+              <a:t>YOU BUILD</a:t>
+            </a:r>
+          </a:p>
+          <a:p>
+            <a:pPr algn="l">
+              <a:lnSpc>
+                <a:spcPct val="108000"/>
+              </a:lnSpc>
+              <a:spcBef>
+                <a:spcPts val="300"/>
+              </a:spcBef>
+              <a:defRPr sz="1350" b="0">
+                <a:solidFill>
+                  <a:srgbClr val="FFFFFF"/>
                 </a:solidFill>
               </a:defRPr>
             </a:pPr>
             <a:r>
-              <a:t>•  No right ranking exists. The scaffolds (tiers, pod shortlist, contacts) disagree on purpose.</a:t>
-            </a:r>
-          </a:p>
-        </p:txBody>
-      </p:sp>
-    </p:spTree>
-  </p:cSld>
-  <p:clrMapOvr>
-    <a:masterClrMapping/>
-  </p:clrMapOvr>
-</p:sld>
-</file>
-
-<file path=ppt/slides/slide5.xml><?xml version="1.0" encoding="utf-8"?>
-<p:sld xmlns:a="http://schemas.openxmlformats.org/drawingml/2006/main" xmlns:p="http://schemas.openxmlformats.org/presentationml/2006/main" xmlns:r="http://schemas.openxmlformats.org/officeDocument/2006/relationships">
-  <p:cSld>
-    <p:spTree>
-      <p:nvGrpSpPr>
-        <p:cNvPr id="1" name=""/>
-        <p:cNvGrpSpPr/>
-        <p:nvPr/>
-      </p:nvGrpSpPr>
-      <p:grpSpPr/>
-      <p:sp>
-        <p:nvSpPr>
-          <p:cNvPr id="2" name="TextBox 1"/>
+              <a:t>A production line: content brief in, on-voice asset out, in the ICP's own language. Every market, every format.</a:t>
+            </a:r>
+          </a:p>
+        </p:txBody>
+      </p:sp>
+      <p:sp>
+        <p:nvSpPr>
+          <p:cNvPr id="10" name="Rounded Rectangle 9"/>
+          <p:cNvSpPr/>
+          <p:nvPr/>
+        </p:nvSpPr>
+        <p:spPr>
+          <a:xfrm>
+            <a:off x="8449056" y="1783080"/>
+            <a:ext cx="3529584" cy="3977639"/>
+          </a:xfrm>
+          <a:prstGeom prst="roundRect">
+            <a:avLst>
+              <a:gd name="adj" fmla="val 3000"/>
+            </a:avLst>
+          </a:prstGeom>
+          <a:solidFill>
+            <a:srgbClr val="1C2D52"/>
+          </a:solidFill>
+          <a:ln>
+            <a:noFill/>
+          </a:ln>
+          <a:effectLst/>
+        </p:spPr>
+        <p:style>
+          <a:lnRef idx="1">
+            <a:schemeClr val="accent1"/>
+          </a:lnRef>
+          <a:fillRef idx="3">
+            <a:schemeClr val="accent1"/>
+          </a:fillRef>
+          <a:effectRef idx="2">
+            <a:schemeClr val="accent1"/>
+          </a:effectRef>
+          <a:fontRef idx="minor">
+            <a:schemeClr val="lt1"/>
+          </a:fontRef>
+        </p:style>
+        <p:txBody>
+          <a:bodyPr rtlCol="0" anchor="ctr"/>
+          <a:lstStyle/>
+          <a:p>
+            <a:pPr algn="ctr"/>
+          </a:p>
+        </p:txBody>
+      </p:sp>
+      <p:sp>
+        <p:nvSpPr>
+          <p:cNvPr id="11" name="TextBox 10"/>
           <p:cNvSpPr txBox="1"/>
           <p:nvPr/>
         </p:nvSpPr>
         <p:spPr>
           <a:xfrm>
-            <a:off x="731520" y="457200"/>
-            <a:ext cx="10698480" cy="914400"/>
+            <a:off x="8759952" y="2039112"/>
+            <a:ext cx="2907792" cy="3465575"/>
           </a:xfrm>
           <a:prstGeom prst="rect">
             <a:avLst/>
@@ -4110,34 +4771,112 @@
           <a:noFill/>
         </p:spPr>
         <p:txBody>
-          <a:bodyPr wrap="none">
+          <a:bodyPr wrap="square">
             <a:spAutoFit/>
           </a:bodyPr>
           <a:lstStyle/>
           <a:p>
-            <a:pPr>
-              <a:defRPr sz="3000" b="1">
-                <a:solidFill>
-                  <a:srgbClr val="1B2A4A"/>
+            <a:r>
+              <a:rPr sz="3400" b="1">
+                <a:solidFill>
+                  <a:srgbClr val="F05A28"/>
+                </a:solidFill>
+              </a:rPr>
+              <a:t>03  </a:t>
+            </a:r>
+            <a:r>
+              <a:rPr sz="1600" b="1">
+                <a:solidFill>
+                  <a:srgbClr val="B9C2D6"/>
+                </a:solidFill>
+              </a:rPr>
+              <a:t>REACH</a:t>
+            </a:r>
+          </a:p>
+          <a:p>
+            <a:pPr algn="l">
+              <a:lnSpc>
+                <a:spcPct val="108000"/>
+              </a:lnSpc>
+              <a:spcBef>
+                <a:spcPts val="200"/>
+              </a:spcBef>
+              <a:defRPr sz="1900" b="1">
+                <a:solidFill>
+                  <a:srgbClr val="FFFFFF"/>
                 </a:solidFill>
               </a:defRPr>
             </a:pPr>
             <a:r>
-              <a:t>Brief 01: five seeded paths, all defensible</a:t>
-            </a:r>
-          </a:p>
-        </p:txBody>
-      </p:sp>
-      <p:sp>
-        <p:nvSpPr>
-          <p:cNvPr id="3" name="TextBox 2"/>
+              <a:t>The Account Penetration Machine</a:t>
+            </a:r>
+          </a:p>
+          <a:p>
+            <a:pPr algn="l">
+              <a:lnSpc>
+                <a:spcPct val="108000"/>
+              </a:lnSpc>
+              <a:spcBef>
+                <a:spcPts val="1000"/>
+              </a:spcBef>
+              <a:defRPr sz="1250" b="0">
+                <a:solidFill>
+                  <a:srgbClr val="B9C2D6"/>
+                </a:solidFill>
+              </a:defRPr>
+            </a:pPr>
+            <a:r>
+              <a:t>Well-researched accounts, barely penetrated. 0.4% replies.</a:t>
+            </a:r>
+          </a:p>
+          <a:p>
+            <a:pPr algn="l">
+              <a:lnSpc>
+                <a:spcPct val="108000"/>
+              </a:lnSpc>
+              <a:spcBef>
+                <a:spcPts val="1400"/>
+              </a:spcBef>
+              <a:defRPr sz="1050" b="1">
+                <a:solidFill>
+                  <a:srgbClr val="F05A28"/>
+                </a:solidFill>
+              </a:defRPr>
+            </a:pPr>
+            <a:r>
+              <a:t>YOU BUILD</a:t>
+            </a:r>
+          </a:p>
+          <a:p>
+            <a:pPr algn="l">
+              <a:lnSpc>
+                <a:spcPct val="108000"/>
+              </a:lnSpc>
+              <a:spcBef>
+                <a:spcPts val="300"/>
+              </a:spcBef>
+              <a:defRPr sz="1350" b="0">
+                <a:solidFill>
+                  <a:srgbClr val="FFFFFF"/>
+                </a:solidFill>
+              </a:defRPr>
+            </a:pPr>
+            <a:r>
+              <a:t>A distribution engine: prioritized account in, the play out. Right door, right person, right moment.</a:t>
+            </a:r>
+          </a:p>
+        </p:txBody>
+      </p:sp>
+      <p:sp>
+        <p:nvSpPr>
+          <p:cNvPr id="12" name="TextBox 11"/>
           <p:cNvSpPr txBox="1"/>
           <p:nvPr/>
         </p:nvSpPr>
         <p:spPr>
           <a:xfrm>
-            <a:off x="731520" y="1143000"/>
-            <a:ext cx="10698480" cy="457200"/>
+            <a:off x="822960" y="5989320"/>
+            <a:ext cx="10607040" cy="457200"/>
           </a:xfrm>
           <a:prstGeom prst="rect">
             <a:avLst/>
@@ -4145,807 +4884,23 @@
           <a:noFill/>
         </p:spPr>
         <p:txBody>
-          <a:bodyPr wrap="none">
-            <a:spAutoFit/>
-          </a:bodyPr>
-          <a:lstStyle/>
-          <a:p>
-            <a:pPr>
-              <a:defRPr sz="1500" i="1">
-                <a:solidFill>
-                  <a:srgbClr val="E85D3D"/>
-                </a:solidFill>
-              </a:defRPr>
-            </a:pPr>
-            <a:r>
-              <a:t>Full detail + evidence trails: mentor-kit/paths-and-hints.md</a:t>
-            </a:r>
-          </a:p>
-        </p:txBody>
-      </p:sp>
-      <p:sp>
-        <p:nvSpPr>
-          <p:cNvPr id="4" name="TextBox 3"/>
-          <p:cNvSpPr txBox="1"/>
-          <p:nvPr/>
-        </p:nvSpPr>
-        <p:spPr>
-          <a:xfrm>
-            <a:off x="731520" y="1691640"/>
-            <a:ext cx="10698480" cy="4846320"/>
-          </a:xfrm>
-          <a:prstGeom prst="rect">
-            <a:avLst/>
-          </a:prstGeom>
-          <a:noFill/>
-        </p:spPr>
-        <p:txBody>
           <a:bodyPr wrap="square">
             <a:spAutoFit/>
           </a:bodyPr>
           <a:lstStyle/>
           <a:p>
-            <a:pPr>
-              <a:spcAft>
-                <a:spcPts val="700"/>
-              </a:spcAft>
-              <a:defRPr sz="1700" b="0">
-                <a:solidFill>
-                  <a:srgbClr val="1B2A4A"/>
-                </a:solidFill>
-              </a:defRPr>
+            <a:pPr algn="l">
+              <a:lnSpc>
+                <a:spcPct val="100000"/>
+              </a:lnSpc>
             </a:pPr>
             <a:r>
-              <a:t>•  Regulation / deadline: live RFP, FINMA, LMS end-of-life. Blind spot: a deadline is not budget.</a:t>
-            </a:r>
-          </a:p>
-          <a:p>
-            <a:pPr>
-              <a:spcAft>
-                <a:spcPts val="700"/>
-              </a:spcAft>
-              <a:defRPr sz="1700" b="0">
-                <a:solidFill>
-                  <a:srgbClr val="1B2A4A"/>
-                </a:solidFill>
-              </a:defRPr>
-            </a:pPr>
-            <a:r>
-              <a:t>•  Leadership change: new CHRO/CPO with a mandate. Blind spot: the interim and cost-cutting decoys.</a:t>
-            </a:r>
-          </a:p>
-          <a:p>
-            <a:pPr>
-              <a:spcAft>
-                <a:spcPts val="700"/>
-              </a:spcAft>
-              <a:defRPr sz="1700" b="0">
-                <a:solidFill>
-                  <a:srgbClr val="1B2A4A"/>
-                </a:solidFill>
-              </a:defRPr>
-            </a:pPr>
-            <a:r>
-              <a:t>•  Competitor displacement: failing incumbents. Blind spot: complaints are not switching intent.</a:t>
-            </a:r>
-          </a:p>
-          <a:p>
-            <a:pPr>
-              <a:spcAft>
-                <a:spcPts val="700"/>
-              </a:spcAft>
-              <a:defRPr sz="1700" b="0">
-                <a:solidFill>
-                  <a:srgbClr val="1B2A4A"/>
-                </a:solidFill>
-              </a:defRPr>
-            </a:pPr>
-            <a:r>
-              <a:t>•  Warm path: every past win was warm; access beats freshness. Blind spot: references spend once.</a:t>
-            </a:r>
-          </a:p>
-          <a:p>
-            <a:pPr>
-              <a:spcAft>
-                <a:spcPts val="700"/>
-              </a:spcAft>
-              <a:defRPr sz="1700" b="0">
-                <a:solidFill>
-                  <a:srgbClr val="1B2A4A"/>
-                </a:solidFill>
-              </a:defRPr>
-            </a:pPr>
-            <a:r>
-              <a:t>•  Burn-aware: respect the send-log; hand-raisers first. Blind spot: past burn is not destiny.</a:t>
-            </a:r>
-          </a:p>
-          <a:p>
-            <a:pPr>
-              <a:spcAft>
-                <a:spcPts val="700"/>
-              </a:spcAft>
-              <a:defRPr sz="1700" b="1">
-                <a:solidFill>
-                  <a:srgbClr val="1B2A4A"/>
-                </a:solidFill>
-              </a:defRPr>
-            </a:pPr>
-            <a:r>
-              <a:t>•  Different paths produce different top-3s. That is the design working, not a team being wrong.</a:t>
-            </a:r>
-          </a:p>
-        </p:txBody>
-      </p:sp>
-    </p:spTree>
-  </p:cSld>
-  <p:clrMapOvr>
-    <a:masterClrMapping/>
-  </p:clrMapOvr>
-</p:sld>
-</file>
-
-<file path=ppt/slides/slide6.xml><?xml version="1.0" encoding="utf-8"?>
-<p:sld xmlns:a="http://schemas.openxmlformats.org/drawingml/2006/main" xmlns:p="http://schemas.openxmlformats.org/presentationml/2006/main" xmlns:r="http://schemas.openxmlformats.org/officeDocument/2006/relationships">
-  <p:cSld>
-    <p:spTree>
-      <p:nvGrpSpPr>
-        <p:cNvPr id="1" name=""/>
-        <p:cNvGrpSpPr/>
-        <p:nvPr/>
-      </p:nvGrpSpPr>
-      <p:grpSpPr/>
-      <p:sp>
-        <p:nvSpPr>
-          <p:cNvPr id="2" name="TextBox 1"/>
-          <p:cNvSpPr txBox="1"/>
-          <p:nvPr/>
-        </p:nvSpPr>
-        <p:spPr>
-          <a:xfrm>
-            <a:off x="731520" y="457200"/>
-            <a:ext cx="10698480" cy="914400"/>
-          </a:xfrm>
-          <a:prstGeom prst="rect">
-            <a:avLst/>
-          </a:prstGeom>
-          <a:noFill/>
-        </p:spPr>
-        <p:txBody>
-          <a:bodyPr wrap="none">
-            <a:spAutoFit/>
-          </a:bodyPr>
-          <a:lstStyle/>
-          <a:p>
-            <a:pPr>
-              <a:defRPr sz="3000" b="1">
-                <a:solidFill>
-                  <a:srgbClr val="1B2A4A"/>
-                </a:solidFill>
-              </a:defRPr>
-            </a:pPr>
-            <a:r>
-              <a:t>Brief 02: The Brand Voice Machine (SPEAK)</a:t>
-            </a:r>
-          </a:p>
-        </p:txBody>
-      </p:sp>
-      <p:sp>
-        <p:nvSpPr>
-          <p:cNvPr id="3" name="TextBox 2"/>
-          <p:cNvSpPr txBox="1"/>
-          <p:nvPr/>
-        </p:nvSpPr>
-        <p:spPr>
-          <a:xfrm>
-            <a:off x="731520" y="1691640"/>
-            <a:ext cx="10698480" cy="4846320"/>
-          </a:xfrm>
-          <a:prstGeom prst="rect">
-            <a:avLst/>
-          </a:prstGeom>
-          <a:noFill/>
-        </p:spPr>
-        <p:txBody>
-          <a:bodyPr wrap="square">
-            <a:spAutoFit/>
-          </a:bodyPr>
-          <a:lstStyle/>
-          <a:p>
-            <a:pPr>
-              <a:spcAft>
-                <a:spcPts val="700"/>
-              </a:spcAft>
-              <a:defRPr sz="1700" b="0">
-                <a:solidFill>
-                  <a:srgbClr val="1B2A4A"/>
-                </a:solidFill>
-              </a:defRPr>
-            </a:pPr>
-            <a:r>
-              <a:t>•  Build: a production line that turns any content brief into an on-voice asset, in any market and language.</a:t>
-            </a:r>
-          </a:p>
-          <a:p>
-            <a:pPr>
-              <a:spcAft>
-                <a:spcPts val="700"/>
-              </a:spcAft>
-              <a:defRPr sz="1700" b="0">
-                <a:solidFill>
-                  <a:srgbClr val="1B2A4A"/>
-                </a:solidFill>
-              </a:defRPr>
-            </a:pPr>
-            <a:r>
-              <a:t>•  Data: voice guide, gold standard, 20-piece corpus, 10 drifted drafts, 6 author samples, a dead German translation.</a:t>
-            </a:r>
-          </a:p>
-          <a:p>
-            <a:pPr>
-              <a:spcAft>
-                <a:spcPts val="700"/>
-              </a:spcAft>
-              <a:defRPr sz="1700" b="0">
-                <a:solidFill>
-                  <a:srgbClr val="1B2A4A"/>
-                </a:solidFill>
-              </a:defRPr>
-            </a:pPr>
-            <a:r>
-              <a:t>•  Winning demo: brief in, German asset out, every voice decision explained. Stretch: a language with no guide.</a:t>
-            </a:r>
-          </a:p>
-          <a:p>
-            <a:pPr>
-              <a:spcAft>
-                <a:spcPts val="700"/>
-              </a:spcAft>
-              <a:defRPr sz="1700" b="1">
-                <a:solidFill>
-                  <a:srgbClr val="1B2A4A"/>
-                </a:solidFill>
-              </a:defRPr>
-            </a:pPr>
-            <a:r>
-              <a:t>•  The guide is one way to codify the voice, not the only one. The labeled drafts test the gate, not the team.</a:t>
-            </a:r>
-          </a:p>
-        </p:txBody>
-      </p:sp>
-    </p:spTree>
-  </p:cSld>
-  <p:clrMapOvr>
-    <a:masterClrMapping/>
-  </p:clrMapOvr>
-</p:sld>
-</file>
-
-<file path=ppt/slides/slide7.xml><?xml version="1.0" encoding="utf-8"?>
-<p:sld xmlns:a="http://schemas.openxmlformats.org/drawingml/2006/main" xmlns:p="http://schemas.openxmlformats.org/presentationml/2006/main" xmlns:r="http://schemas.openxmlformats.org/officeDocument/2006/relationships">
-  <p:cSld>
-    <p:spTree>
-      <p:nvGrpSpPr>
-        <p:cNvPr id="1" name=""/>
-        <p:cNvGrpSpPr/>
-        <p:nvPr/>
-      </p:nvGrpSpPr>
-      <p:grpSpPr/>
-      <p:sp>
-        <p:nvSpPr>
-          <p:cNvPr id="2" name="TextBox 1"/>
-          <p:cNvSpPr txBox="1"/>
-          <p:nvPr/>
-        </p:nvSpPr>
-        <p:spPr>
-          <a:xfrm>
-            <a:off x="731520" y="457200"/>
-            <a:ext cx="10698480" cy="914400"/>
-          </a:xfrm>
-          <a:prstGeom prst="rect">
-            <a:avLst/>
-          </a:prstGeom>
-          <a:noFill/>
-        </p:spPr>
-        <p:txBody>
-          <a:bodyPr wrap="none">
-            <a:spAutoFit/>
-          </a:bodyPr>
-          <a:lstStyle/>
-          <a:p>
-            <a:pPr>
-              <a:defRPr sz="3000" b="1">
-                <a:solidFill>
-                  <a:srgbClr val="1B2A4A"/>
-                </a:solidFill>
-              </a:defRPr>
-            </a:pPr>
-            <a:r>
-              <a:t>Brief 02: six seeded machines, all defensible</a:t>
-            </a:r>
-          </a:p>
-        </p:txBody>
-      </p:sp>
-      <p:sp>
-        <p:nvSpPr>
-          <p:cNvPr id="3" name="TextBox 2"/>
-          <p:cNvSpPr txBox="1"/>
-          <p:nvPr/>
-        </p:nvSpPr>
-        <p:spPr>
-          <a:xfrm>
-            <a:off x="731520" y="1143000"/>
-            <a:ext cx="10698480" cy="457200"/>
-          </a:xfrm>
-          <a:prstGeom prst="rect">
-            <a:avLst/>
-          </a:prstGeom>
-          <a:noFill/>
-        </p:spPr>
-        <p:txBody>
-          <a:bodyPr wrap="none">
-            <a:spAutoFit/>
-          </a:bodyPr>
-          <a:lstStyle/>
-          <a:p>
-            <a:pPr>
-              <a:defRPr sz="1500" i="1">
-                <a:solidFill>
-                  <a:srgbClr val="E85D3D"/>
-                </a:solidFill>
-              </a:defRPr>
-            </a:pPr>
-            <a:r>
-              <a:t>Full detail + evidence trails: mentor-kit/paths-and-hints.md</a:t>
-            </a:r>
-          </a:p>
-        </p:txBody>
-      </p:sp>
-      <p:sp>
-        <p:nvSpPr>
-          <p:cNvPr id="4" name="TextBox 3"/>
-          <p:cNvSpPr txBox="1"/>
-          <p:nvPr/>
-        </p:nvSpPr>
-        <p:spPr>
-          <a:xfrm>
-            <a:off x="731520" y="1691640"/>
-            <a:ext cx="10698480" cy="4846320"/>
-          </a:xfrm>
-          <a:prstGeom prst="rect">
-            <a:avLst/>
-          </a:prstGeom>
-          <a:noFill/>
-        </p:spPr>
-        <p:txBody>
-          <a:bodyPr wrap="square">
-            <a:spAutoFit/>
-          </a:bodyPr>
-          <a:lstStyle/>
-          <a:p>
-            <a:pPr>
-              <a:spcAft>
-                <a:spcPts val="700"/>
-              </a:spcAft>
-              <a:defRPr sz="1700" b="0">
-                <a:solidFill>
-                  <a:srgbClr val="1B2A4A"/>
-                </a:solidFill>
-              </a:defRPr>
-            </a:pPr>
-            <a:r>
-              <a:t>•  Rules-first gate: codify the guide. Blind spot: zero banned words can still be generic.</a:t>
-            </a:r>
-          </a:p>
-          <a:p>
-            <a:pPr>
-              <a:spcAft>
-                <a:spcPts val="700"/>
-              </a:spcAft>
-              <a:defRPr sz="1700" b="0">
-                <a:solidFill>
-                  <a:srgbClr val="1B2A4A"/>
-                </a:solidFill>
-              </a:defRPr>
-            </a:pPr>
-            <a:r>
-              <a:t>•  Exemplar matcher: 'does it sound like the corpus?' Blind spot: flags well, explains poorly.</a:t>
-            </a:r>
-          </a:p>
-          <a:p>
-            <a:pPr>
-              <a:spcAft>
-                <a:spcPts val="700"/>
-              </a:spcAft>
-              <a:defRPr sz="1700" b="0">
-                <a:solidFill>
-                  <a:srgbClr val="1B2A4A"/>
-                </a:solidFill>
-              </a:defRPr>
-            </a:pPr>
-            <a:r>
-              <a:t>•  Author profiles: model each writer's drift. Blind spot: thin data per author.</a:t>
-            </a:r>
-          </a:p>
-          <a:p>
-            <a:pPr>
-              <a:spcAft>
-                <a:spcPts val="700"/>
-              </a:spcAft>
-              <a:defRPr sz="1700" b="0">
-                <a:solidFill>
-                  <a:srgbClr val="1B2A4A"/>
-                </a:solidFill>
-              </a:defRPr>
-            </a:pPr>
-            <a:r>
-              <a:t>•  Transcreation-first: the language crossing is the engine. Blind spot: neglects the production belt.</a:t>
-            </a:r>
-          </a:p>
-          <a:p>
-            <a:pPr>
-              <a:spcAft>
-                <a:spcPts val="700"/>
-              </a:spcAft>
-              <a:defRPr sz="1700" b="0">
-                <a:solidFill>
-                  <a:srgbClr val="1B2A4A"/>
-                </a:solidFill>
-              </a:defRPr>
-            </a:pPr>
-            <a:r>
-              <a:t>•  Producer-first: center on brief-to-asset; the gate is one step. Blind spot: weak gate ships drift at scale.</a:t>
-            </a:r>
-          </a:p>
-          <a:p>
-            <a:pPr>
-              <a:spcAft>
-                <a:spcPts val="700"/>
-              </a:spcAft>
-              <a:defRPr sz="1700" b="0">
-                <a:solidFill>
-                  <a:srgbClr val="1B2A4A"/>
-                </a:solidFill>
-              </a:defRPr>
-            </a:pPr>
-            <a:r>
-              <a:t>•  Config voice-OS: new language = new config. Blind spot: abstraction eats the afternoon.</a:t>
-            </a:r>
-          </a:p>
-        </p:txBody>
-      </p:sp>
-    </p:spTree>
-  </p:cSld>
-  <p:clrMapOvr>
-    <a:masterClrMapping/>
-  </p:clrMapOvr>
-</p:sld>
-</file>
-
-<file path=ppt/slides/slide8.xml><?xml version="1.0" encoding="utf-8"?>
-<p:sld xmlns:a="http://schemas.openxmlformats.org/drawingml/2006/main" xmlns:p="http://schemas.openxmlformats.org/presentationml/2006/main" xmlns:r="http://schemas.openxmlformats.org/officeDocument/2006/relationships">
-  <p:cSld>
-    <p:spTree>
-      <p:nvGrpSpPr>
-        <p:cNvPr id="1" name=""/>
-        <p:cNvGrpSpPr/>
-        <p:nvPr/>
-      </p:nvGrpSpPr>
-      <p:grpSpPr/>
-      <p:sp>
-        <p:nvSpPr>
-          <p:cNvPr id="2" name="TextBox 1"/>
-          <p:cNvSpPr txBox="1"/>
-          <p:nvPr/>
-        </p:nvSpPr>
-        <p:spPr>
-          <a:xfrm>
-            <a:off x="731520" y="457200"/>
-            <a:ext cx="10698480" cy="914400"/>
-          </a:xfrm>
-          <a:prstGeom prst="rect">
-            <a:avLst/>
-          </a:prstGeom>
-          <a:noFill/>
-        </p:spPr>
-        <p:txBody>
-          <a:bodyPr wrap="none">
-            <a:spAutoFit/>
-          </a:bodyPr>
-          <a:lstStyle/>
-          <a:p>
-            <a:pPr>
-              <a:defRPr sz="3000" b="1">
-                <a:solidFill>
-                  <a:srgbClr val="1B2A4A"/>
-                </a:solidFill>
-              </a:defRPr>
-            </a:pPr>
-            <a:r>
-              <a:t>Brief 03: The Account Penetration Machine (REACH)</a:t>
-            </a:r>
-          </a:p>
-        </p:txBody>
-      </p:sp>
-      <p:sp>
-        <p:nvSpPr>
-          <p:cNvPr id="3" name="TextBox 2"/>
-          <p:cNvSpPr txBox="1"/>
-          <p:nvPr/>
-        </p:nvSpPr>
-        <p:spPr>
-          <a:xfrm>
-            <a:off x="731520" y="1691640"/>
-            <a:ext cx="10698480" cy="4846320"/>
-          </a:xfrm>
-          <a:prstGeom prst="rect">
-            <a:avLst/>
-          </a:prstGeom>
-          <a:noFill/>
-        </p:spPr>
-        <p:txBody>
-          <a:bodyPr wrap="square">
-            <a:spAutoFit/>
-          </a:bodyPr>
-          <a:lstStyle/>
-          <a:p>
-            <a:pPr>
-              <a:spcAft>
-                <a:spcPts val="700"/>
-              </a:spcAft>
-              <a:defRPr sz="1700" b="0">
-                <a:solidFill>
-                  <a:srgbClr val="1B2A4A"/>
-                </a:solidFill>
-              </a:defRPr>
-            </a:pPr>
-            <a:r>
-              <a:t>•  Build: prioritized accounts in, outreach out. Right door (email, LinkedIn, call, reference, event, gift), right person, right moment.</a:t>
-            </a:r>
-          </a:p>
-          <a:p>
-            <a:pPr>
-              <a:spcAft>
-                <a:spcPts val="700"/>
-              </a:spcAft>
-              <a:defRPr sz="1700" b="0">
-                <a:solidFill>
-                  <a:srgbClr val="1B2A4A"/>
-                </a:solidFill>
-              </a:defRPr>
-            </a:pPr>
-            <a:r>
-              <a:t>•  Data: 50 accounts, 130 contacts, send-log burn state, warm paths, call notes, the 0.4% baseline.</a:t>
-            </a:r>
-          </a:p>
-          <a:p>
-            <a:pPr>
-              <a:spcAft>
-                <a:spcPts val="700"/>
-              </a:spcAft>
-              <a:defRPr sz="1700" b="0">
-                <a:solidFill>
-                  <a:srgbClr val="1B2A4A"/>
-                </a:solidFill>
-              </a:defRPr>
-            </a:pPr>
-            <a:r>
-              <a:t>•  Winning demo: one hot account in, a complete attack plan out. Then the next account, live.</a:t>
-            </a:r>
-          </a:p>
-          <a:p>
-            <a:pPr>
-              <a:spcAft>
-                <a:spcPts val="700"/>
-              </a:spcAft>
-              <a:defRPr sz="1700" b="1">
-                <a:solidFill>
-                  <a:srgbClr val="1B2A4A"/>
-                </a:solidFill>
-              </a:defRPr>
-            </a:pPr>
-            <a:r>
-              <a:t>•  Brief 02 writes the message. This team orders it and distributes it. Copywriting here is scope drift.</a:t>
-            </a:r>
-          </a:p>
-        </p:txBody>
-      </p:sp>
-    </p:spTree>
-  </p:cSld>
-  <p:clrMapOvr>
-    <a:masterClrMapping/>
-  </p:clrMapOvr>
-</p:sld>
-</file>
-
-<file path=ppt/slides/slide9.xml><?xml version="1.0" encoding="utf-8"?>
-<p:sld xmlns:a="http://schemas.openxmlformats.org/drawingml/2006/main" xmlns:p="http://schemas.openxmlformats.org/presentationml/2006/main" xmlns:r="http://schemas.openxmlformats.org/officeDocument/2006/relationships">
-  <p:cSld>
-    <p:spTree>
-      <p:nvGrpSpPr>
-        <p:cNvPr id="1" name=""/>
-        <p:cNvGrpSpPr/>
-        <p:nvPr/>
-      </p:nvGrpSpPr>
-      <p:grpSpPr/>
-      <p:sp>
-        <p:nvSpPr>
-          <p:cNvPr id="2" name="TextBox 1"/>
-          <p:cNvSpPr txBox="1"/>
-          <p:nvPr/>
-        </p:nvSpPr>
-        <p:spPr>
-          <a:xfrm>
-            <a:off x="731520" y="457200"/>
-            <a:ext cx="10698480" cy="914400"/>
-          </a:xfrm>
-          <a:prstGeom prst="rect">
-            <a:avLst/>
-          </a:prstGeom>
-          <a:noFill/>
-        </p:spPr>
-        <p:txBody>
-          <a:bodyPr wrap="none">
-            <a:spAutoFit/>
-          </a:bodyPr>
-          <a:lstStyle/>
-          <a:p>
-            <a:pPr>
-              <a:defRPr sz="3000" b="1">
-                <a:solidFill>
-                  <a:srgbClr val="1B2A4A"/>
-                </a:solidFill>
-              </a:defRPr>
-            </a:pPr>
-            <a:r>
-              <a:t>Brief 03: six seeded motions, all defensible</a:t>
-            </a:r>
-          </a:p>
-        </p:txBody>
-      </p:sp>
-      <p:sp>
-        <p:nvSpPr>
-          <p:cNvPr id="3" name="TextBox 2"/>
-          <p:cNvSpPr txBox="1"/>
-          <p:nvPr/>
-        </p:nvSpPr>
-        <p:spPr>
-          <a:xfrm>
-            <a:off x="731520" y="1143000"/>
-            <a:ext cx="10698480" cy="457200"/>
-          </a:xfrm>
-          <a:prstGeom prst="rect">
-            <a:avLst/>
-          </a:prstGeom>
-          <a:noFill/>
-        </p:spPr>
-        <p:txBody>
-          <a:bodyPr wrap="none">
-            <a:spAutoFit/>
-          </a:bodyPr>
-          <a:lstStyle/>
-          <a:p>
-            <a:pPr>
-              <a:defRPr sz="1500" i="1">
-                <a:solidFill>
-                  <a:srgbClr val="E85D3D"/>
-                </a:solidFill>
-              </a:defRPr>
-            </a:pPr>
-            <a:r>
-              <a:t>Full detail + evidence trails: mentor-kit/paths-and-hints.md</a:t>
-            </a:r>
-          </a:p>
-        </p:txBody>
-      </p:sp>
-      <p:sp>
-        <p:nvSpPr>
-          <p:cNvPr id="4" name="TextBox 3"/>
-          <p:cNvSpPr txBox="1"/>
-          <p:nvPr/>
-        </p:nvSpPr>
-        <p:spPr>
-          <a:xfrm>
-            <a:off x="731520" y="1691640"/>
-            <a:ext cx="10698480" cy="4846320"/>
-          </a:xfrm>
-          <a:prstGeom prst="rect">
-            <a:avLst/>
-          </a:prstGeom>
-          <a:noFill/>
-        </p:spPr>
-        <p:txBody>
-          <a:bodyPr wrap="square">
-            <a:spAutoFit/>
-          </a:bodyPr>
-          <a:lstStyle/>
-          <a:p>
-            <a:pPr>
-              <a:spcAft>
-                <a:spcPts val="700"/>
-              </a:spcAft>
-              <a:defRPr sz="1700" b="0">
-                <a:solidFill>
-                  <a:srgbClr val="1B2A4A"/>
-                </a:solidFill>
-              </a:defRPr>
-            </a:pPr>
-            <a:r>
-              <a:t>•  Signal-first: freshest trigger gets the next touch. Blind spot: signal-rich can be burned.</a:t>
-            </a:r>
-          </a:p>
-          <a:p>
-            <a:pPr>
-              <a:spcAft>
-                <a:spcPts val="700"/>
-              </a:spcAft>
-              <a:defRPr sz="1700" b="0">
-                <a:solidFill>
-                  <a:srgbClr val="1B2A4A"/>
-                </a:solidFill>
-              </a:defRPr>
-            </a:pPr>
-            <a:r>
-              <a:t>•  Hand-raiser first: 4 positive replies last quarter, zero follow-up. Blind spot: only four accounts.</a:t>
-            </a:r>
-          </a:p>
-          <a:p>
-            <a:pPr>
-              <a:spcAft>
-                <a:spcPts val="700"/>
-              </a:spcAft>
-              <a:defRPr sz="1700" b="0">
-                <a:solidFill>
-                  <a:srgbClr val="1B2A4A"/>
-                </a:solidFill>
-              </a:defRPr>
-            </a:pPr>
-            <a:r>
-              <a:t>•  Warm path: spend the 9 beachhead relationships deliberately. Blind spot: scarce and one-shot.</a:t>
-            </a:r>
-          </a:p>
-          <a:p>
-            <a:pPr>
-              <a:spcAft>
-                <a:spcPts val="700"/>
-              </a:spcAft>
-              <a:defRPr sz="1700" b="0">
-                <a:solidFill>
-                  <a:srgbClr val="1B2A4A"/>
-                </a:solidFill>
-              </a:defRPr>
-            </a:pPr>
-            <a:r>
-              <a:t>•  Event-anchored: go where buyers already are. Blind spot: slow cadence, hard to demo.</a:t>
-            </a:r>
-          </a:p>
-          <a:p>
-            <a:pPr>
-              <a:spcAft>
-                <a:spcPts val="700"/>
-              </a:spcAft>
-              <a:defRPr sz="1700" b="0">
-                <a:solidFill>
-                  <a:srgbClr val="1B2A4A"/>
-                </a:solidFill>
-              </a:defRPr>
-            </a:pPr>
-            <a:r>
-              <a:t>•  Clean-list first: 7 accounts never touched. Blind spot: untouched often means weaker fit.</a:t>
-            </a:r>
-          </a:p>
-          <a:p>
-            <a:pPr>
-              <a:spcAft>
-                <a:spcPts val="700"/>
-              </a:spcAft>
-              <a:defRPr sz="1700" b="0">
-                <a:solidFill>
-                  <a:srgbClr val="1B2A4A"/>
-                </a:solidFill>
-              </a:defRPr>
-            </a:pPr>
-            <a:r>
-              <a:t>•  Channel-switch: 20+ opens, zero replies = wrong door. Blind spot: opens are a weak signal.</a:t>
+              <a:rPr sz="1400" b="1">
+                <a:solidFill>
+                  <a:srgbClr val="5E6675"/>
+                </a:solidFill>
+              </a:rPr>
+              <a:t>Each team gets one brief. Each brief stands alone. And remember: it is a full system.</a:t>
             </a:r>
           </a:p>
         </p:txBody>

</xml_diff>